<commit_message>
Simplify final project presentation slides
</commit_message>
<xml_diff>
--- a/透明物体/汇报/透明物体多层深度_简洁汇报_2026-08-08.pptx
+++ b/透明物体/汇报/透明物体多层深度_简洁汇报_2026-08-08.pptx
@@ -8426,7 +8426,7 @@
                 </a:solidFill>
                 <a:latin typeface="Microsoft YaHei"/>
               </a:rPr>
-              <a:t>目前复现进度：哪些是论文协议，哪些是我们的诊断</a:t>
+              <a:t>复现进度：已经证明什么，还缺什么</a:t>
             </a:r>
           </a:p>
         </p:txBody>
@@ -8474,8 +8474,8 @@
         </p:nvSpPr>
         <p:spPr>
           <a:xfrm>
-            <a:off x="603504" y="1152144"/>
-            <a:ext cx="2834640" cy="219456"/>
+            <a:off x="603504" y="1161288"/>
+            <a:ext cx="2103120" cy="219456"/>
           </a:xfrm>
           <a:prstGeom prst="rect">
             <a:avLst/>
@@ -8496,7 +8496,7 @@
                 </a:solidFill>
                 <a:latin typeface="Microsoft YaHei"/>
               </a:rPr>
-              <a:t>官方协议 / benchmark</a:t>
+              <a:t>已完成的证据</a:t>
             </a:r>
           </a:p>
         </p:txBody>
@@ -8509,8 +8509,8 @@
         </p:nvSpPr>
         <p:spPr>
           <a:xfrm>
-            <a:off x="2962656" y="1106424"/>
-            <a:ext cx="1060704" cy="292608"/>
+            <a:off x="5806440" y="1115568"/>
+            <a:ext cx="1115568" cy="292608"/>
           </a:xfrm>
           <a:prstGeom prst="roundRect">
             <a:avLst/>
@@ -8554,8 +8554,8 @@
         </p:nvSpPr>
         <p:spPr>
           <a:xfrm>
-            <a:off x="2962656" y="1175004"/>
-            <a:ext cx="1060704" cy="118872"/>
+            <a:off x="5806440" y="1184148"/>
+            <a:ext cx="1115568" cy="118872"/>
           </a:xfrm>
           <a:prstGeom prst="rect">
             <a:avLst/>
@@ -8576,7 +8576,7 @@
                 </a:solidFill>
                 <a:latin typeface="Microsoft YaHei"/>
               </a:rPr>
-              <a:t>可直接引用</a:t>
+              <a:t>结果可信</a:t>
             </a:r>
           </a:p>
         </p:txBody>
@@ -8589,8 +8589,8 @@
         </p:nvSpPr>
         <p:spPr>
           <a:xfrm>
-            <a:off x="603504" y="1636776"/>
-            <a:ext cx="5385816" cy="1005840"/>
+            <a:off x="603504" y="1600200"/>
+            <a:ext cx="6528816" cy="987552"/>
           </a:xfrm>
           <a:prstGeom prst="roundRect">
             <a:avLst/>
@@ -8628,14 +8628,59 @@
       </p:sp>
       <p:sp>
         <p:nvSpPr>
-          <p:cNvPr id="9" name="TextBox 8"/>
-          <p:cNvSpPr txBox="1"/>
-          <p:nvPr/>
-        </p:nvSpPr>
-        <p:spPr>
-          <a:xfrm>
-            <a:off x="841248" y="1801368"/>
-            <a:ext cx="2212848" cy="182880"/>
+          <p:cNvPr id="9" name="Rectangle 8"/>
+          <p:cNvSpPr/>
+          <p:nvPr/>
+        </p:nvSpPr>
+        <p:spPr>
+          <a:xfrm>
+            <a:off x="603504" y="1600200"/>
+            <a:ext cx="64008" cy="987552"/>
+          </a:xfrm>
+          <a:prstGeom prst="rect">
+            <a:avLst/>
+          </a:prstGeom>
+          <a:solidFill>
+            <a:srgbClr val="15805D"/>
+          </a:solidFill>
+          <a:ln w="10160">
+            <a:solidFill>
+              <a:srgbClr val="15805D"/>
+            </a:solidFill>
+          </a:ln>
+        </p:spPr>
+        <p:style>
+          <a:lnRef idx="1">
+            <a:schemeClr val="accent1"/>
+          </a:lnRef>
+          <a:fillRef idx="3">
+            <a:schemeClr val="accent1"/>
+          </a:fillRef>
+          <a:effectRef idx="2">
+            <a:schemeClr val="accent1"/>
+          </a:effectRef>
+          <a:fontRef idx="minor">
+            <a:schemeClr val="lt1"/>
+          </a:fontRef>
+        </p:style>
+        <p:txBody>
+          <a:bodyPr rtlCol="0" anchor="ctr"/>
+          <a:lstStyle/>
+          <a:p>
+            <a:pPr algn="ctr"/>
+          </a:p>
+        </p:txBody>
+      </p:sp>
+      <p:sp>
+        <p:nvSpPr>
+          <p:cNvPr id="10" name="TextBox 9"/>
+          <p:cNvSpPr txBox="1"/>
+          <p:nvPr/>
+        </p:nvSpPr>
+        <p:spPr>
+          <a:xfrm>
+            <a:off x="841248" y="1755648"/>
+            <a:ext cx="1901952" cy="192024"/>
           </a:xfrm>
           <a:prstGeom prst="rect">
             <a:avLst/>
@@ -8656,21 +8701,21 @@
                 </a:solidFill>
                 <a:latin typeface="Microsoft YaHei"/>
               </a:rPr>
-              <a:t>Depth4ToM Base path</a:t>
-            </a:r>
-          </a:p>
-        </p:txBody>
-      </p:sp>
-      <p:sp>
-        <p:nvSpPr>
-          <p:cNvPr id="10" name="TextBox 9"/>
-          <p:cNvSpPr txBox="1"/>
-          <p:nvPr/>
-        </p:nvSpPr>
-        <p:spPr>
-          <a:xfrm>
-            <a:off x="841248" y="2148840"/>
-            <a:ext cx="2212848" cy="164592"/>
+              <a:t>单层深度基线</a:t>
+            </a:r>
+          </a:p>
+        </p:txBody>
+      </p:sp>
+      <p:sp>
+        <p:nvSpPr>
+          <p:cNvPr id="11" name="TextBox 10"/>
+          <p:cNvSpPr txBox="1"/>
+          <p:nvPr/>
+        </p:nvSpPr>
+        <p:spPr>
+          <a:xfrm>
+            <a:off x="841248" y="2112264"/>
+            <a:ext cx="1901952" cy="164592"/>
           </a:xfrm>
           <a:prstGeom prst="rect">
             <a:avLst/>
@@ -8691,21 +8736,21 @@
                 </a:solidFill>
                 <a:latin typeface="Microsoft YaHei"/>
               </a:rPr>
-              <a:t>Booster 228</a:t>
-            </a:r>
-          </a:p>
-        </p:txBody>
-      </p:sp>
-      <p:sp>
-        <p:nvSpPr>
-          <p:cNvPr id="11" name="TextBox 10"/>
-          <p:cNvSpPr txBox="1"/>
-          <p:nvPr/>
-        </p:nvSpPr>
-        <p:spPr>
-          <a:xfrm>
-            <a:off x="3054096" y="1801368"/>
-            <a:ext cx="2496312" cy="201168"/>
+              <a:t>Booster · 228 张</a:t>
+            </a:r>
+          </a:p>
+        </p:txBody>
+      </p:sp>
+      <p:sp>
+        <p:nvSpPr>
+          <p:cNvPr id="12" name="TextBox 11"/>
+          <p:cNvSpPr txBox="1"/>
+          <p:nvPr/>
+        </p:nvSpPr>
+        <p:spPr>
+          <a:xfrm>
+            <a:off x="2788920" y="1746504"/>
+            <a:ext cx="3931920" cy="210312"/>
           </a:xfrm>
           <a:prstGeom prst="rect">
             <a:avLst/>
@@ -8720,27 +8765,27 @@
           <a:p>
             <a:pPr algn="r"/>
             <a:r>
-              <a:rPr sz="1160" b="1">
-                <a:solidFill>
-                  <a:srgbClr val="0F766E"/>
-                </a:solidFill>
-                <a:latin typeface="Microsoft YaHei"/>
-              </a:rPr>
-              <a:t>DPT ToM RMSE 136.28 mm</a:t>
-            </a:r>
-          </a:p>
-        </p:txBody>
-      </p:sp>
-      <p:sp>
-        <p:nvSpPr>
-          <p:cNvPr id="12" name="TextBox 11"/>
-          <p:cNvSpPr txBox="1"/>
-          <p:nvPr/>
-        </p:nvSpPr>
-        <p:spPr>
-          <a:xfrm>
-            <a:off x="3054096" y="2167128"/>
-            <a:ext cx="2496312" cy="164592"/>
+              <a:rPr sz="1110" b="1">
+                <a:solidFill>
+                  <a:srgbClr val="15805D"/>
+                </a:solidFill>
+                <a:latin typeface="Microsoft YaHei"/>
+              </a:rPr>
+              <a:t>均方根误差 136.28 mm（约 13.6 cm）</a:t>
+            </a:r>
+          </a:p>
+        </p:txBody>
+      </p:sp>
+      <p:sp>
+        <p:nvSpPr>
+          <p:cNvPr id="13" name="TextBox 12"/>
+          <p:cNvSpPr txBox="1"/>
+          <p:nvPr/>
+        </p:nvSpPr>
+        <p:spPr>
+          <a:xfrm>
+            <a:off x="2788920" y="2121408"/>
+            <a:ext cx="3931920" cy="164592"/>
           </a:xfrm>
           <a:prstGeom prst="rect">
             <a:avLst/>
@@ -8755,27 +8800,27 @@
           <a:p>
             <a:pPr algn="r"/>
             <a:r>
-              <a:rPr sz="919" b="1">
-                <a:solidFill>
-                  <a:srgbClr val="15805D"/>
-                </a:solidFill>
-                <a:latin typeface="Microsoft YaHei"/>
-              </a:rPr>
-              <a:t>与论文一致</a:t>
-            </a:r>
-          </a:p>
-        </p:txBody>
-      </p:sp>
-      <p:sp>
-        <p:nvSpPr>
-          <p:cNvPr id="13" name="Rounded Rectangle 12"/>
+              <a:rPr sz="890" b="0">
+                <a:solidFill>
+                  <a:srgbClr val="667381"/>
+                </a:solidFill>
+                <a:latin typeface="Microsoft YaHei"/>
+              </a:rPr>
+              <a:t>与论文表格一致</a:t>
+            </a:r>
+          </a:p>
+        </p:txBody>
+      </p:sp>
+      <p:sp>
+        <p:nvSpPr>
+          <p:cNvPr id="14" name="Rounded Rectangle 13"/>
           <p:cNvSpPr/>
           <p:nvPr/>
         </p:nvSpPr>
         <p:spPr>
           <a:xfrm>
-            <a:off x="603504" y="2889504"/>
-            <a:ext cx="5385816" cy="1005840"/>
+            <a:off x="603504" y="2724912"/>
+            <a:ext cx="6528816" cy="987552"/>
           </a:xfrm>
           <a:prstGeom prst="roundRect">
             <a:avLst/>
@@ -8813,14 +8858,59 @@
       </p:sp>
       <p:sp>
         <p:nvSpPr>
-          <p:cNvPr id="14" name="TextBox 13"/>
-          <p:cNvSpPr txBox="1"/>
-          <p:nvPr/>
-        </p:nvSpPr>
-        <p:spPr>
-          <a:xfrm>
-            <a:off x="841248" y="3054096"/>
-            <a:ext cx="2212848" cy="182880"/>
+          <p:cNvPr id="15" name="Rectangle 14"/>
+          <p:cNvSpPr/>
+          <p:nvPr/>
+        </p:nvSpPr>
+        <p:spPr>
+          <a:xfrm>
+            <a:off x="603504" y="2724912"/>
+            <a:ext cx="64008" cy="987552"/>
+          </a:xfrm>
+          <a:prstGeom prst="rect">
+            <a:avLst/>
+          </a:prstGeom>
+          <a:solidFill>
+            <a:srgbClr val="0F766E"/>
+          </a:solidFill>
+          <a:ln w="10160">
+            <a:solidFill>
+              <a:srgbClr val="0F766E"/>
+            </a:solidFill>
+          </a:ln>
+        </p:spPr>
+        <p:style>
+          <a:lnRef idx="1">
+            <a:schemeClr val="accent1"/>
+          </a:lnRef>
+          <a:fillRef idx="3">
+            <a:schemeClr val="accent1"/>
+          </a:fillRef>
+          <a:effectRef idx="2">
+            <a:schemeClr val="accent1"/>
+          </a:effectRef>
+          <a:fontRef idx="minor">
+            <a:schemeClr val="lt1"/>
+          </a:fontRef>
+        </p:style>
+        <p:txBody>
+          <a:bodyPr rtlCol="0" anchor="ctr"/>
+          <a:lstStyle/>
+          <a:p>
+            <a:pPr algn="ctr"/>
+          </a:p>
+        </p:txBody>
+      </p:sp>
+      <p:sp>
+        <p:nvSpPr>
+          <p:cNvPr id="16" name="TextBox 15"/>
+          <p:cNvSpPr txBox="1"/>
+          <p:nvPr/>
+        </p:nvSpPr>
+        <p:spPr>
+          <a:xfrm>
+            <a:off x="841248" y="2880360"/>
+            <a:ext cx="1901952" cy="192024"/>
           </a:xfrm>
           <a:prstGeom prst="rect">
             <a:avLst/>
@@ -8841,21 +8931,21 @@
                 </a:solidFill>
                 <a:latin typeface="Microsoft YaHei"/>
               </a:rPr>
-              <a:t>DPT Base vs SeeGroup</a:t>
-            </a:r>
-          </a:p>
-        </p:txBody>
-      </p:sp>
-      <p:sp>
-        <p:nvSpPr>
-          <p:cNvPr id="15" name="TextBox 14"/>
-          <p:cNvSpPr txBox="1"/>
-          <p:nvPr/>
-        </p:nvSpPr>
-        <p:spPr>
-          <a:xfrm>
-            <a:off x="841248" y="3401568"/>
-            <a:ext cx="2212848" cy="164592"/>
+              <a:t>多层深度对比</a:t>
+            </a:r>
+          </a:p>
+        </p:txBody>
+      </p:sp>
+      <p:sp>
+        <p:nvSpPr>
+          <p:cNvPr id="17" name="TextBox 16"/>
+          <p:cNvSpPr txBox="1"/>
+          <p:nvPr/>
+        </p:nvSpPr>
+        <p:spPr>
+          <a:xfrm>
+            <a:off x="841248" y="3236976"/>
+            <a:ext cx="1901952" cy="164592"/>
           </a:xfrm>
           <a:prstGeom prst="rect">
             <a:avLst/>
@@ -8876,21 +8966,21 @@
                 </a:solidFill>
                 <a:latin typeface="Microsoft YaHei"/>
               </a:rPr>
-              <a:t>LayeredDepth val 300</a:t>
-            </a:r>
-          </a:p>
-        </p:txBody>
-      </p:sp>
-      <p:sp>
-        <p:nvSpPr>
-          <p:cNvPr id="16" name="TextBox 15"/>
-          <p:cNvSpPr txBox="1"/>
-          <p:nvPr/>
-        </p:nvSpPr>
-        <p:spPr>
-          <a:xfrm>
-            <a:off x="3054096" y="3054096"/>
-            <a:ext cx="2496312" cy="201168"/>
+              <a:t>LayeredDepth · 300 张</a:t>
+            </a:r>
+          </a:p>
+        </p:txBody>
+      </p:sp>
+      <p:sp>
+        <p:nvSpPr>
+          <p:cNvPr id="18" name="TextBox 17"/>
+          <p:cNvSpPr txBox="1"/>
+          <p:nvPr/>
+        </p:nvSpPr>
+        <p:spPr>
+          <a:xfrm>
+            <a:off x="2788920" y="2871216"/>
+            <a:ext cx="3931920" cy="210312"/>
           </a:xfrm>
           <a:prstGeom prst="rect">
             <a:avLst/>
@@ -8905,27 +8995,27 @@
           <a:p>
             <a:pPr algn="r"/>
             <a:r>
-              <a:rPr sz="1160" b="1">
+              <a:rPr sz="1110" b="1">
                 <a:solidFill>
                   <a:srgbClr val="0F766E"/>
                 </a:solidFill>
                 <a:latin typeface="Microsoft YaHei"/>
               </a:rPr>
-              <a:t>layer_all 29.95% → 72.41%</a:t>
-            </a:r>
-          </a:p>
-        </p:txBody>
-      </p:sp>
-      <p:sp>
-        <p:nvSpPr>
-          <p:cNvPr id="17" name="TextBox 16"/>
-          <p:cNvSpPr txBox="1"/>
-          <p:nvPr/>
-        </p:nvSpPr>
-        <p:spPr>
-          <a:xfrm>
-            <a:off x="3054096" y="3419856"/>
-            <a:ext cx="2496312" cy="164592"/>
+              <a:t>4 个界面顺序全对：29.95% → 72.41%</a:t>
+            </a:r>
+          </a:p>
+        </p:txBody>
+      </p:sp>
+      <p:sp>
+        <p:nvSpPr>
+          <p:cNvPr id="19" name="TextBox 18"/>
+          <p:cNvSpPr txBox="1"/>
+          <p:nvPr/>
+        </p:nvSpPr>
+        <p:spPr>
+          <a:xfrm>
+            <a:off x="2788920" y="3246120"/>
+            <a:ext cx="3931920" cy="164592"/>
           </a:xfrm>
           <a:prstGeom prst="rect">
             <a:avLst/>
@@ -8940,27 +9030,117 @@
           <a:p>
             <a:pPr algn="r"/>
             <a:r>
-              <a:rPr sz="919" b="1">
-                <a:solidFill>
-                  <a:srgbClr val="15805D"/>
-                </a:solidFill>
-                <a:latin typeface="Microsoft YaHei"/>
-              </a:rPr>
-              <a:t>+42.46 pp</a:t>
-            </a:r>
-          </a:p>
-        </p:txBody>
-      </p:sp>
-      <p:sp>
-        <p:nvSpPr>
-          <p:cNvPr id="18" name="TextBox 17"/>
-          <p:cNvSpPr txBox="1"/>
-          <p:nvPr/>
-        </p:nvSpPr>
-        <p:spPr>
-          <a:xfrm>
-            <a:off x="6272784" y="1152144"/>
-            <a:ext cx="2834640" cy="219456"/>
+              <a:rPr sz="890" b="0">
+                <a:solidFill>
+                  <a:srgbClr val="667381"/>
+                </a:solidFill>
+                <a:latin typeface="Microsoft YaHei"/>
+              </a:rPr>
+              <a:t>多层模型明显更完整</a:t>
+            </a:r>
+          </a:p>
+        </p:txBody>
+      </p:sp>
+      <p:sp>
+        <p:nvSpPr>
+          <p:cNvPr id="20" name="Rounded Rectangle 19"/>
+          <p:cNvSpPr/>
+          <p:nvPr/>
+        </p:nvSpPr>
+        <p:spPr>
+          <a:xfrm>
+            <a:off x="603504" y="3849624"/>
+            <a:ext cx="6528816" cy="987552"/>
+          </a:xfrm>
+          <a:prstGeom prst="roundRect">
+            <a:avLst/>
+          </a:prstGeom>
+          <a:solidFill>
+            <a:srgbClr val="FFFFFF"/>
+          </a:solidFill>
+          <a:ln w="10160">
+            <a:solidFill>
+              <a:srgbClr val="DDE3E8"/>
+            </a:solidFill>
+          </a:ln>
+        </p:spPr>
+        <p:style>
+          <a:lnRef idx="1">
+            <a:schemeClr val="accent1"/>
+          </a:lnRef>
+          <a:fillRef idx="3">
+            <a:schemeClr val="accent1"/>
+          </a:fillRef>
+          <a:effectRef idx="2">
+            <a:schemeClr val="accent1"/>
+          </a:effectRef>
+          <a:fontRef idx="minor">
+            <a:schemeClr val="lt1"/>
+          </a:fontRef>
+        </p:style>
+        <p:txBody>
+          <a:bodyPr rtlCol="0" anchor="ctr"/>
+          <a:lstStyle/>
+          <a:p>
+            <a:pPr algn="ctr"/>
+          </a:p>
+        </p:txBody>
+      </p:sp>
+      <p:sp>
+        <p:nvSpPr>
+          <p:cNvPr id="21" name="Rectangle 20"/>
+          <p:cNvSpPr/>
+          <p:nvPr/>
+        </p:nvSpPr>
+        <p:spPr>
+          <a:xfrm>
+            <a:off x="603504" y="3849624"/>
+            <a:ext cx="64008" cy="987552"/>
+          </a:xfrm>
+          <a:prstGeom prst="rect">
+            <a:avLst/>
+          </a:prstGeom>
+          <a:solidFill>
+            <a:srgbClr val="C46B16"/>
+          </a:solidFill>
+          <a:ln w="10160">
+            <a:solidFill>
+              <a:srgbClr val="C46B16"/>
+            </a:solidFill>
+          </a:ln>
+        </p:spPr>
+        <p:style>
+          <a:lnRef idx="1">
+            <a:schemeClr val="accent1"/>
+          </a:lnRef>
+          <a:fillRef idx="3">
+            <a:schemeClr val="accent1"/>
+          </a:fillRef>
+          <a:effectRef idx="2">
+            <a:schemeClr val="accent1"/>
+          </a:effectRef>
+          <a:fontRef idx="minor">
+            <a:schemeClr val="lt1"/>
+          </a:fontRef>
+        </p:style>
+        <p:txBody>
+          <a:bodyPr rtlCol="0" anchor="ctr"/>
+          <a:lstStyle/>
+          <a:p>
+            <a:pPr algn="ctr"/>
+          </a:p>
+        </p:txBody>
+      </p:sp>
+      <p:sp>
+        <p:nvSpPr>
+          <p:cNvPr id="22" name="TextBox 21"/>
+          <p:cNvSpPr txBox="1"/>
+          <p:nvPr/>
+        </p:nvSpPr>
+        <p:spPr>
+          <a:xfrm>
+            <a:off x="841248" y="4005072"/>
+            <a:ext cx="1901952" cy="192024"/>
           </a:xfrm>
           <a:prstGeom prst="rect">
             <a:avLst/>
@@ -8975,27 +9155,167 @@
           <a:p>
             <a:pPr algn="l"/>
             <a:r>
+              <a:rPr sz="1150" b="1">
+                <a:solidFill>
+                  <a:srgbClr val="172331"/>
+                </a:solidFill>
+                <a:latin typeface="Microsoft YaHei"/>
+              </a:rPr>
+              <a:t>薄壳几何检查</a:t>
+            </a:r>
+          </a:p>
+        </p:txBody>
+      </p:sp>
+      <p:sp>
+        <p:nvSpPr>
+          <p:cNvPr id="23" name="TextBox 22"/>
+          <p:cNvSpPr txBox="1"/>
+          <p:nvPr/>
+        </p:nvSpPr>
+        <p:spPr>
+          <a:xfrm>
+            <a:off x="841248" y="4361688"/>
+            <a:ext cx="1901952" cy="164592"/>
+          </a:xfrm>
+          <a:prstGeom prst="rect">
+            <a:avLst/>
+          </a:prstGeom>
+          <a:noFill/>
+        </p:spPr>
+        <p:txBody>
+          <a:bodyPr wrap="square" lIns="18288" rIns="18288" tIns="18288" bIns="18288" anchor="t">
+            <a:spAutoFit/>
+          </a:bodyPr>
+          <a:lstStyle/>
+          <a:p>
+            <a:pPr algn="l"/>
+            <a:r>
+              <a:rPr sz="900" b="0">
+                <a:solidFill>
+                  <a:srgbClr val="667381"/>
+                </a:solidFill>
+                <a:latin typeface="Microsoft YaHei"/>
+              </a:rPr>
+              <a:t>TablewareNet · 100 个场景</a:t>
+            </a:r>
+          </a:p>
+        </p:txBody>
+      </p:sp>
+      <p:sp>
+        <p:nvSpPr>
+          <p:cNvPr id="24" name="TextBox 23"/>
+          <p:cNvSpPr txBox="1"/>
+          <p:nvPr/>
+        </p:nvSpPr>
+        <p:spPr>
+          <a:xfrm>
+            <a:off x="2788920" y="3995928"/>
+            <a:ext cx="3931920" cy="210312"/>
+          </a:xfrm>
+          <a:prstGeom prst="rect">
+            <a:avLst/>
+          </a:prstGeom>
+          <a:noFill/>
+        </p:spPr>
+        <p:txBody>
+          <a:bodyPr wrap="square" lIns="18288" rIns="18288" tIns="18288" bIns="18288" anchor="t">
+            <a:spAutoFit/>
+          </a:bodyPr>
+          <a:lstStyle/>
+          <a:p>
+            <a:pPr algn="r"/>
+            <a:r>
+              <a:rPr sz="1110" b="1">
+                <a:solidFill>
+                  <a:srgbClr val="C46B16"/>
+                </a:solidFill>
+                <a:latin typeface="Microsoft YaHei"/>
+              </a:rPr>
+              <a:t>已知真实物体区域时，界面识别 F1 = 79.15%</a:t>
+            </a:r>
+          </a:p>
+        </p:txBody>
+      </p:sp>
+      <p:sp>
+        <p:nvSpPr>
+          <p:cNvPr id="25" name="TextBox 24"/>
+          <p:cNvSpPr txBox="1"/>
+          <p:nvPr/>
+        </p:nvSpPr>
+        <p:spPr>
+          <a:xfrm>
+            <a:off x="2788920" y="4370832"/>
+            <a:ext cx="3931920" cy="164592"/>
+          </a:xfrm>
+          <a:prstGeom prst="rect">
+            <a:avLst/>
+          </a:prstGeom>
+          <a:noFill/>
+        </p:spPr>
+        <p:txBody>
+          <a:bodyPr wrap="square" lIns="18288" rIns="18288" tIns="18288" bIns="18288" anchor="t">
+            <a:spAutoFit/>
+          </a:bodyPr>
+          <a:lstStyle/>
+          <a:p>
+            <a:pPr algn="r"/>
+            <a:r>
+              <a:rPr sz="890" b="0">
+                <a:solidFill>
+                  <a:srgbClr val="667381"/>
+                </a:solidFill>
+                <a:latin typeface="Microsoft YaHei"/>
+              </a:rPr>
+              <a:t>说明几何路线可行，不是论文正式分数</a:t>
+            </a:r>
+          </a:p>
+        </p:txBody>
+      </p:sp>
+      <p:sp>
+        <p:nvSpPr>
+          <p:cNvPr id="26" name="TextBox 25"/>
+          <p:cNvSpPr txBox="1"/>
+          <p:nvPr/>
+        </p:nvSpPr>
+        <p:spPr>
+          <a:xfrm>
+            <a:off x="7370064" y="1161288"/>
+            <a:ext cx="1920240" cy="219456"/>
+          </a:xfrm>
+          <a:prstGeom prst="rect">
+            <a:avLst/>
+          </a:prstGeom>
+          <a:noFill/>
+        </p:spPr>
+        <p:txBody>
+          <a:bodyPr wrap="square" lIns="18288" rIns="18288" tIns="18288" bIns="18288" anchor="t">
+            <a:spAutoFit/>
+          </a:bodyPr>
+          <a:lstStyle/>
+          <a:p>
+            <a:pPr algn="l"/>
+            <a:r>
               <a:rPr sz="1400" b="1">
                 <a:solidFill>
                   <a:srgbClr val="172331"/>
                 </a:solidFill>
                 <a:latin typeface="Microsoft YaHei"/>
               </a:rPr>
-              <a:t>我们的诊断 / oracle</a:t>
-            </a:r>
-          </a:p>
-        </p:txBody>
-      </p:sp>
-      <p:sp>
-        <p:nvSpPr>
-          <p:cNvPr id="19" name="Rounded Rectangle 18"/>
+              <a:t>仍未完成</a:t>
+            </a:r>
+          </a:p>
+        </p:txBody>
+      </p:sp>
+      <p:sp>
+        <p:nvSpPr>
+          <p:cNvPr id="27" name="Rounded Rectangle 26"/>
           <p:cNvSpPr/>
           <p:nvPr/>
         </p:nvSpPr>
         <p:spPr>
           <a:xfrm>
-            <a:off x="9838944" y="1106424"/>
-            <a:ext cx="1554480" cy="292608"/>
+            <a:off x="10305288" y="1115568"/>
+            <a:ext cx="1280160" cy="292608"/>
           </a:xfrm>
           <a:prstGeom prst="roundRect">
             <a:avLst/>
@@ -9033,14 +9353,14 @@
       </p:sp>
       <p:sp>
         <p:nvSpPr>
-          <p:cNvPr id="20" name="TextBox 19"/>
-          <p:cNvSpPr txBox="1"/>
-          <p:nvPr/>
-        </p:nvSpPr>
-        <p:spPr>
-          <a:xfrm>
-            <a:off x="9838944" y="1175004"/>
-            <a:ext cx="1554480" cy="118872"/>
+          <p:cNvPr id="28" name="TextBox 27"/>
+          <p:cNvSpPr txBox="1"/>
+          <p:nvPr/>
+        </p:nvSpPr>
+        <p:spPr>
+          <a:xfrm>
+            <a:off x="10305288" y="1184148"/>
+            <a:ext cx="1280160" cy="118872"/>
           </a:xfrm>
           <a:prstGeom prst="rect">
             <a:avLst/>
@@ -9061,21 +9381,21 @@
                 </a:solidFill>
                 <a:latin typeface="Microsoft YaHei"/>
               </a:rPr>
-              <a:t>不能冒充论文分数</a:t>
-            </a:r>
-          </a:p>
-        </p:txBody>
-      </p:sp>
-      <p:sp>
-        <p:nvSpPr>
-          <p:cNvPr id="21" name="Rounded Rectangle 20"/>
+              <a:t>暂不下结论</a:t>
+            </a:r>
+          </a:p>
+        </p:txBody>
+      </p:sp>
+      <p:sp>
+        <p:nvSpPr>
+          <p:cNvPr id="29" name="Rounded Rectangle 28"/>
           <p:cNvSpPr/>
           <p:nvPr/>
         </p:nvSpPr>
         <p:spPr>
           <a:xfrm>
-            <a:off x="6272784" y="1636776"/>
-            <a:ext cx="5312664" cy="1005840"/>
+            <a:off x="7370064" y="1600200"/>
+            <a:ext cx="4215384" cy="1554480"/>
           </a:xfrm>
           <a:prstGeom prst="roundRect">
             <a:avLst/>
@@ -9113,14 +9433,59 @@
       </p:sp>
       <p:sp>
         <p:nvSpPr>
-          <p:cNvPr id="22" name="TextBox 21"/>
-          <p:cNvSpPr txBox="1"/>
-          <p:nvPr/>
-        </p:nvSpPr>
-        <p:spPr>
-          <a:xfrm>
-            <a:off x="6510528" y="1801368"/>
-            <a:ext cx="2267712" cy="182880"/>
+          <p:cNvPr id="30" name="Rectangle 29"/>
+          <p:cNvSpPr/>
+          <p:nvPr/>
+        </p:nvSpPr>
+        <p:spPr>
+          <a:xfrm>
+            <a:off x="7370064" y="1600200"/>
+            <a:ext cx="64008" cy="1554480"/>
+          </a:xfrm>
+          <a:prstGeom prst="rect">
+            <a:avLst/>
+          </a:prstGeom>
+          <a:solidFill>
+            <a:srgbClr val="C46B16"/>
+          </a:solidFill>
+          <a:ln w="10160">
+            <a:solidFill>
+              <a:srgbClr val="C46B16"/>
+            </a:solidFill>
+          </a:ln>
+        </p:spPr>
+        <p:style>
+          <a:lnRef idx="1">
+            <a:schemeClr val="accent1"/>
+          </a:lnRef>
+          <a:fillRef idx="3">
+            <a:schemeClr val="accent1"/>
+          </a:fillRef>
+          <a:effectRef idx="2">
+            <a:schemeClr val="accent1"/>
+          </a:effectRef>
+          <a:fontRef idx="minor">
+            <a:schemeClr val="lt1"/>
+          </a:fontRef>
+        </p:style>
+        <p:txBody>
+          <a:bodyPr rtlCol="0" anchor="ctr"/>
+          <a:lstStyle/>
+          <a:p>
+            <a:pPr algn="ctr"/>
+          </a:p>
+        </p:txBody>
+      </p:sp>
+      <p:sp>
+        <p:nvSpPr>
+          <p:cNvPr id="31" name="TextBox 30"/>
+          <p:cNvSpPr txBox="1"/>
+          <p:nvPr/>
+        </p:nvSpPr>
+        <p:spPr>
+          <a:xfrm>
+            <a:off x="7626096" y="1792224"/>
+            <a:ext cx="3666744" cy="210312"/>
           </a:xfrm>
           <a:prstGeom prst="rect">
             <a:avLst/>
@@ -9135,27 +9500,27 @@
           <a:p>
             <a:pPr algn="l"/>
             <a:r>
-              <a:rPr sz="1150" b="1">
+              <a:rPr sz="1220" b="1">
                 <a:solidFill>
                   <a:srgbClr val="172331"/>
                 </a:solidFill>
                 <a:latin typeface="Microsoft YaHei"/>
               </a:rPr>
-              <a:t>T²SQNet + GT mask</a:t>
-            </a:r>
-          </a:p>
-        </p:txBody>
-      </p:sp>
-      <p:sp>
-        <p:nvSpPr>
-          <p:cNvPr id="23" name="TextBox 22"/>
-          <p:cNvSpPr txBox="1"/>
-          <p:nvPr/>
-        </p:nvSpPr>
-        <p:spPr>
-          <a:xfrm>
-            <a:off x="6510528" y="2148840"/>
-            <a:ext cx="2267712" cy="164592"/>
+              <a:t>TransCG 全量测试</a:t>
+            </a:r>
+          </a:p>
+        </p:txBody>
+      </p:sp>
+      <p:sp>
+        <p:nvSpPr>
+          <p:cNvPr id="32" name="TextBox 31"/>
+          <p:cNvSpPr txBox="1"/>
+          <p:nvPr/>
+        </p:nvSpPr>
+        <p:spPr>
+          <a:xfrm>
+            <a:off x="7626096" y="2148840"/>
+            <a:ext cx="3666744" cy="182880"/>
           </a:xfrm>
           <a:prstGeom prst="rect">
             <a:avLst/>
@@ -9170,40 +9535,40 @@
           <a:p>
             <a:pPr algn="l"/>
             <a:r>
-              <a:rPr sz="900" b="0">
+              <a:rPr sz="930" b="0">
                 <a:solidFill>
                   <a:srgbClr val="667381"/>
                 </a:solidFill>
                 <a:latin typeface="Microsoft YaHei"/>
               </a:rPr>
-              <a:t>TablewareNet 100 scenes</a:t>
-            </a:r>
-          </a:p>
-        </p:txBody>
-      </p:sp>
-      <p:sp>
-        <p:nvSpPr>
-          <p:cNvPr id="24" name="TextBox 23"/>
-          <p:cNvSpPr txBox="1"/>
-          <p:nvPr/>
-        </p:nvSpPr>
-        <p:spPr>
-          <a:xfrm>
-            <a:off x="8741664" y="1801368"/>
-            <a:ext cx="2404872" cy="201168"/>
-          </a:xfrm>
-          <a:prstGeom prst="rect">
-            <a:avLst/>
-          </a:prstGeom>
-          <a:noFill/>
-        </p:spPr>
-        <p:txBody>
-          <a:bodyPr wrap="square" lIns="18288" rIns="18288" tIns="18288" bIns="18288" anchor="t">
-            <a:spAutoFit/>
-          </a:bodyPr>
-          <a:lstStyle/>
-          <a:p>
-            <a:pPr algn="r"/>
+              <a:t>需要 52 个场景 / 23,524 个样本</a:t>
+            </a:r>
+          </a:p>
+        </p:txBody>
+      </p:sp>
+      <p:sp>
+        <p:nvSpPr>
+          <p:cNvPr id="33" name="TextBox 32"/>
+          <p:cNvSpPr txBox="1"/>
+          <p:nvPr/>
+        </p:nvSpPr>
+        <p:spPr>
+          <a:xfrm>
+            <a:off x="7626096" y="2496312"/>
+            <a:ext cx="3666744" cy="201168"/>
+          </a:xfrm>
+          <a:prstGeom prst="rect">
+            <a:avLst/>
+          </a:prstGeom>
+          <a:noFill/>
+        </p:spPr>
+        <p:txBody>
+          <a:bodyPr wrap="square" lIns="18288" rIns="18288" tIns="18288" bIns="18288" anchor="t">
+            <a:spAutoFit/>
+          </a:bodyPr>
+          <a:lstStyle/>
+          <a:p>
+            <a:pPr algn="l"/>
             <a:r>
               <a:rPr sz="1130" b="1">
                 <a:solidFill>
@@ -9211,56 +9576,56 @@
                 </a:solidFill>
                 <a:latin typeface="Microsoft YaHei"/>
               </a:rPr>
-              <a:t>Shell interface F1 79.15%</a:t>
-            </a:r>
-          </a:p>
-        </p:txBody>
-      </p:sp>
-      <p:sp>
-        <p:nvSpPr>
-          <p:cNvPr id="25" name="TextBox 24"/>
-          <p:cNvSpPr txBox="1"/>
-          <p:nvPr/>
-        </p:nvSpPr>
-        <p:spPr>
-          <a:xfrm>
-            <a:off x="8741664" y="2167128"/>
-            <a:ext cx="2404872" cy="164592"/>
-          </a:xfrm>
-          <a:prstGeom prst="rect">
-            <a:avLst/>
-          </a:prstGeom>
-          <a:noFill/>
-        </p:spPr>
-        <p:txBody>
-          <a:bodyPr wrap="square" lIns="18288" rIns="18288" tIns="18288" bIns="18288" anchor="t">
-            <a:spAutoFit/>
-          </a:bodyPr>
-          <a:lstStyle/>
-          <a:p>
-            <a:pPr algn="r"/>
-            <a:r>
-              <a:rPr sz="919" b="1">
-                <a:solidFill>
-                  <a:srgbClr val="C46B16"/>
-                </a:solidFill>
-                <a:latin typeface="Microsoft YaHei"/>
-              </a:rPr>
-              <a:t>受控几何 oracle</a:t>
-            </a:r>
-          </a:p>
-        </p:txBody>
-      </p:sp>
-      <p:sp>
-        <p:nvSpPr>
-          <p:cNvPr id="26" name="Rounded Rectangle 25"/>
+              <a:t>已取得 40 / 52 个场景</a:t>
+            </a:r>
+          </a:p>
+        </p:txBody>
+      </p:sp>
+      <p:sp>
+        <p:nvSpPr>
+          <p:cNvPr id="34" name="TextBox 33"/>
+          <p:cNvSpPr txBox="1"/>
+          <p:nvPr/>
+        </p:nvSpPr>
+        <p:spPr>
+          <a:xfrm>
+            <a:off x="7626096" y="2825496"/>
+            <a:ext cx="3666744" cy="164592"/>
+          </a:xfrm>
+          <a:prstGeom prst="rect">
+            <a:avLst/>
+          </a:prstGeom>
+          <a:noFill/>
+        </p:spPr>
+        <p:txBody>
+          <a:bodyPr wrap="square" lIns="18288" rIns="18288" tIns="18288" bIns="18288" anchor="t">
+            <a:spAutoFit/>
+          </a:bodyPr>
+          <a:lstStyle/>
+          <a:p>
+            <a:pPr algn="l"/>
+            <a:r>
+              <a:rPr sz="890" b="0">
+                <a:solidFill>
+                  <a:srgbClr val="667381"/>
+                </a:solidFill>
+                <a:latin typeface="Microsoft YaHei"/>
+              </a:rPr>
+              <a:t>缺少 12 个场景，暂不报最终指标</a:t>
+            </a:r>
+          </a:p>
+        </p:txBody>
+      </p:sp>
+      <p:sp>
+        <p:nvSpPr>
+          <p:cNvPr id="35" name="Rounded Rectangle 34"/>
           <p:cNvSpPr/>
           <p:nvPr/>
         </p:nvSpPr>
         <p:spPr>
           <a:xfrm>
-            <a:off x="6272784" y="2889504"/>
-            <a:ext cx="5312664" cy="1005840"/>
+            <a:off x="7370064" y="3346704"/>
+            <a:ext cx="4215384" cy="1554480"/>
           </a:xfrm>
           <a:prstGeom prst="roundRect">
             <a:avLst/>
@@ -9298,14 +9663,59 @@
       </p:sp>
       <p:sp>
         <p:nvSpPr>
-          <p:cNvPr id="27" name="TextBox 26"/>
-          <p:cNvSpPr txBox="1"/>
-          <p:nvPr/>
-        </p:nvSpPr>
-        <p:spPr>
-          <a:xfrm>
-            <a:off x="6510528" y="3054096"/>
-            <a:ext cx="2267712" cy="182880"/>
+          <p:cNvPr id="36" name="Rectangle 35"/>
+          <p:cNvSpPr/>
+          <p:nvPr/>
+        </p:nvSpPr>
+        <p:spPr>
+          <a:xfrm>
+            <a:off x="7370064" y="3346704"/>
+            <a:ext cx="64008" cy="1554480"/>
+          </a:xfrm>
+          <a:prstGeom prst="rect">
+            <a:avLst/>
+          </a:prstGeom>
+          <a:solidFill>
+            <a:srgbClr val="C46B16"/>
+          </a:solidFill>
+          <a:ln w="10160">
+            <a:solidFill>
+              <a:srgbClr val="C46B16"/>
+            </a:solidFill>
+          </a:ln>
+        </p:spPr>
+        <p:style>
+          <a:lnRef idx="1">
+            <a:schemeClr val="accent1"/>
+          </a:lnRef>
+          <a:fillRef idx="3">
+            <a:schemeClr val="accent1"/>
+          </a:fillRef>
+          <a:effectRef idx="2">
+            <a:schemeClr val="accent1"/>
+          </a:effectRef>
+          <a:fontRef idx="minor">
+            <a:schemeClr val="lt1"/>
+          </a:fontRef>
+        </p:style>
+        <p:txBody>
+          <a:bodyPr rtlCol="0" anchor="ctr"/>
+          <a:lstStyle/>
+          <a:p>
+            <a:pPr algn="ctr"/>
+          </a:p>
+        </p:txBody>
+      </p:sp>
+      <p:sp>
+        <p:nvSpPr>
+          <p:cNvPr id="37" name="TextBox 36"/>
+          <p:cNvSpPr txBox="1"/>
+          <p:nvPr/>
+        </p:nvSpPr>
+        <p:spPr>
+          <a:xfrm>
+            <a:off x="7626096" y="3538728"/>
+            <a:ext cx="3666744" cy="210312"/>
           </a:xfrm>
           <a:prstGeom prst="rect">
             <a:avLst/>
@@ -9320,27 +9730,27 @@
           <a:p>
             <a:pPr algn="l"/>
             <a:r>
-              <a:rPr sz="1150" b="1">
+              <a:rPr sz="1220" b="1">
                 <a:solidFill>
                   <a:srgbClr val="172331"/>
                 </a:solidFill>
                 <a:latin typeface="Microsoft YaHei"/>
               </a:rPr>
-              <a:t>TransCG full test</a:t>
-            </a:r>
-          </a:p>
-        </p:txBody>
-      </p:sp>
-      <p:sp>
-        <p:nvSpPr>
-          <p:cNvPr id="28" name="TextBox 27"/>
-          <p:cNvSpPr txBox="1"/>
-          <p:nvPr/>
-        </p:nvSpPr>
-        <p:spPr>
-          <a:xfrm>
-            <a:off x="6510528" y="3401568"/>
-            <a:ext cx="2267712" cy="164592"/>
+              <a:t>机器人抓取收益</a:t>
+            </a:r>
+          </a:p>
+        </p:txBody>
+      </p:sp>
+      <p:sp>
+        <p:nvSpPr>
+          <p:cNvPr id="38" name="TextBox 37"/>
+          <p:cNvSpPr txBox="1"/>
+          <p:nvPr/>
+        </p:nvSpPr>
+        <p:spPr>
+          <a:xfrm>
+            <a:off x="7626096" y="3895344"/>
+            <a:ext cx="3666744" cy="182880"/>
           </a:xfrm>
           <a:prstGeom prst="rect">
             <a:avLst/>
@@ -9355,40 +9765,40 @@
           <a:p>
             <a:pPr algn="l"/>
             <a:r>
-              <a:rPr sz="900" b="0">
+              <a:rPr sz="930" b="0">
                 <a:solidFill>
                   <a:srgbClr val="667381"/>
                 </a:solidFill>
                 <a:latin typeface="Microsoft YaHei"/>
               </a:rPr>
-              <a:t>52 scenes / 23,524 samples</a:t>
-            </a:r>
-          </a:p>
-        </p:txBody>
-      </p:sp>
-      <p:sp>
-        <p:nvSpPr>
-          <p:cNvPr id="29" name="TextBox 28"/>
-          <p:cNvSpPr txBox="1"/>
-          <p:nvPr/>
-        </p:nvSpPr>
-        <p:spPr>
-          <a:xfrm>
-            <a:off x="8741664" y="3054096"/>
-            <a:ext cx="2404872" cy="201168"/>
-          </a:xfrm>
-          <a:prstGeom prst="rect">
-            <a:avLst/>
-          </a:prstGeom>
-          <a:noFill/>
-        </p:spPr>
-        <p:txBody>
-          <a:bodyPr wrap="square" lIns="18288" rIns="18288" tIns="18288" bIns="18288" anchor="t">
-            <a:spAutoFit/>
-          </a:bodyPr>
-          <a:lstStyle/>
-          <a:p>
-            <a:pPr algn="r"/>
+              <a:t>还没有公平比较单层与多层输入</a:t>
+            </a:r>
+          </a:p>
+        </p:txBody>
+      </p:sp>
+      <p:sp>
+        <p:nvSpPr>
+          <p:cNvPr id="39" name="TextBox 38"/>
+          <p:cNvSpPr txBox="1"/>
+          <p:nvPr/>
+        </p:nvSpPr>
+        <p:spPr>
+          <a:xfrm>
+            <a:off x="7626096" y="4242816"/>
+            <a:ext cx="3666744" cy="201168"/>
+          </a:xfrm>
+          <a:prstGeom prst="rect">
+            <a:avLst/>
+          </a:prstGeom>
+          <a:noFill/>
+        </p:spPr>
+        <p:txBody>
+          <a:bodyPr wrap="square" lIns="18288" rIns="18288" tIns="18288" bIns="18288" anchor="t">
+            <a:spAutoFit/>
+          </a:bodyPr>
+          <a:lstStyle/>
+          <a:p>
+            <a:pPr algn="l"/>
             <a:r>
               <a:rPr sz="1130" b="1">
                 <a:solidFill>
@@ -9396,56 +9806,56 @@
                 </a:solidFill>
                 <a:latin typeface="Microsoft YaHei"/>
               </a:rPr>
-              <a:t>当前已取得 40 / 52 scenes</a:t>
-            </a:r>
-          </a:p>
-        </p:txBody>
-      </p:sp>
-      <p:sp>
-        <p:nvSpPr>
-          <p:cNvPr id="30" name="TextBox 29"/>
-          <p:cNvSpPr txBox="1"/>
-          <p:nvPr/>
-        </p:nvSpPr>
-        <p:spPr>
-          <a:xfrm>
-            <a:off x="8741664" y="3419856"/>
-            <a:ext cx="2404872" cy="164592"/>
-          </a:xfrm>
-          <a:prstGeom prst="rect">
-            <a:avLst/>
-          </a:prstGeom>
-          <a:noFill/>
-        </p:spPr>
-        <p:txBody>
-          <a:bodyPr wrap="square" lIns="18288" rIns="18288" tIns="18288" bIns="18288" anchor="t">
-            <a:spAutoFit/>
-          </a:bodyPr>
-          <a:lstStyle/>
-          <a:p>
-            <a:pPr algn="r"/>
-            <a:r>
-              <a:rPr sz="919" b="1">
-                <a:solidFill>
-                  <a:srgbClr val="C46B16"/>
-                </a:solidFill>
-                <a:latin typeface="Microsoft YaHei"/>
-              </a:rPr>
-              <a:t>尚无 full metric</a:t>
-            </a:r>
-          </a:p>
-        </p:txBody>
-      </p:sp>
-      <p:sp>
-        <p:nvSpPr>
-          <p:cNvPr id="31" name="Rounded Rectangle 30"/>
+              <a:t>尚无抓取成功率结论</a:t>
+            </a:r>
+          </a:p>
+        </p:txBody>
+      </p:sp>
+      <p:sp>
+        <p:nvSpPr>
+          <p:cNvPr id="40" name="TextBox 39"/>
+          <p:cNvSpPr txBox="1"/>
+          <p:nvPr/>
+        </p:nvSpPr>
+        <p:spPr>
+          <a:xfrm>
+            <a:off x="7626096" y="4572000"/>
+            <a:ext cx="3666744" cy="164592"/>
+          </a:xfrm>
+          <a:prstGeom prst="rect">
+            <a:avLst/>
+          </a:prstGeom>
+          <a:noFill/>
+        </p:spPr>
+        <p:txBody>
+          <a:bodyPr wrap="square" lIns="18288" rIns="18288" tIns="18288" bIns="18288" anchor="t">
+            <a:spAutoFit/>
+          </a:bodyPr>
+          <a:lstStyle/>
+          <a:p>
+            <a:pPr algn="l"/>
+            <a:r>
+              <a:rPr sz="890" b="0">
+                <a:solidFill>
+                  <a:srgbClr val="667381"/>
+                </a:solidFill>
+                <a:latin typeface="Microsoft YaHei"/>
+              </a:rPr>
+              <a:t>下一页用同一规划器直接验证</a:t>
+            </a:r>
+          </a:p>
+        </p:txBody>
+      </p:sp>
+      <p:sp>
+        <p:nvSpPr>
+          <p:cNvPr id="41" name="Rounded Rectangle 40"/>
           <p:cNvSpPr/>
           <p:nvPr/>
         </p:nvSpPr>
         <p:spPr>
           <a:xfrm>
-            <a:off x="786384" y="4498848"/>
-            <a:ext cx="10588752" cy="1060704"/>
+            <a:off x="786384" y="5230368"/>
+            <a:ext cx="10588752" cy="786384"/>
           </a:xfrm>
           <a:prstGeom prst="roundRect">
             <a:avLst/>
@@ -9483,14 +9893,14 @@
       </p:sp>
       <p:sp>
         <p:nvSpPr>
-          <p:cNvPr id="32" name="TextBox 31"/>
-          <p:cNvSpPr txBox="1"/>
-          <p:nvPr/>
-        </p:nvSpPr>
-        <p:spPr>
-          <a:xfrm>
-            <a:off x="1051560" y="4727448"/>
-            <a:ext cx="1152144" cy="201168"/>
+          <p:cNvPr id="42" name="TextBox 41"/>
+          <p:cNvSpPr txBox="1"/>
+          <p:nvPr/>
+        </p:nvSpPr>
+        <p:spPr>
+          <a:xfrm>
+            <a:off x="1042415" y="5486400"/>
+            <a:ext cx="1261872" cy="201168"/>
           </a:xfrm>
           <a:prstGeom prst="rect">
             <a:avLst/>
@@ -9511,21 +9921,21 @@
                 </a:solidFill>
                 <a:latin typeface="Microsoft YaHei"/>
               </a:rPr>
-              <a:t>当前能说</a:t>
-            </a:r>
-          </a:p>
-        </p:txBody>
-      </p:sp>
-      <p:sp>
-        <p:nvSpPr>
-          <p:cNvPr id="33" name="TextBox 32"/>
-          <p:cNvSpPr txBox="1"/>
-          <p:nvPr/>
-        </p:nvSpPr>
-        <p:spPr>
-          <a:xfrm>
-            <a:off x="2084831" y="4718304"/>
-            <a:ext cx="8823960" cy="219456"/>
+              <a:t>目前结论</a:t>
+            </a:r>
+          </a:p>
+        </p:txBody>
+      </p:sp>
+      <p:sp>
+        <p:nvSpPr>
+          <p:cNvPr id="43" name="TextBox 42"/>
+          <p:cNvSpPr txBox="1"/>
+          <p:nvPr/>
+        </p:nvSpPr>
+        <p:spPr>
+          <a:xfrm>
+            <a:off x="2203704" y="5449824"/>
+            <a:ext cx="8750808" cy="283464"/>
           </a:xfrm>
           <a:prstGeom prst="rect">
             <a:avLst/>
@@ -9540,90 +9950,20 @@
           <a:p>
             <a:pPr algn="l"/>
             <a:r>
-              <a:rPr sz="1300" b="1">
+              <a:rPr sz="1320" b="1">
                 <a:solidFill>
                   <a:srgbClr val="172331"/>
                 </a:solidFill>
                 <a:latin typeface="Microsoft YaHei"/>
               </a:rPr>
-              <a:t>多层表示在感知协议上优势显著；受控条件下能够恢复大量薄壳界面。</a:t>
-            </a:r>
-          </a:p>
-        </p:txBody>
-      </p:sp>
-      <p:sp>
-        <p:nvSpPr>
-          <p:cNvPr id="34" name="TextBox 33"/>
-          <p:cNvSpPr txBox="1"/>
-          <p:nvPr/>
-        </p:nvSpPr>
-        <p:spPr>
-          <a:xfrm>
-            <a:off x="1051560" y="5138928"/>
-            <a:ext cx="1152144" cy="201168"/>
-          </a:xfrm>
-          <a:prstGeom prst="rect">
-            <a:avLst/>
-          </a:prstGeom>
-          <a:noFill/>
-        </p:spPr>
-        <p:txBody>
-          <a:bodyPr wrap="square" lIns="18288" rIns="18288" tIns="18288" bIns="18288" anchor="t">
-            <a:spAutoFit/>
-          </a:bodyPr>
-          <a:lstStyle/>
-          <a:p>
-            <a:pPr algn="l"/>
-            <a:r>
-              <a:rPr sz="1200" b="1">
-                <a:solidFill>
-                  <a:srgbClr val="B7443E"/>
-                </a:solidFill>
-                <a:latin typeface="Microsoft YaHei"/>
-              </a:rPr>
-              <a:t>当前不能说</a:t>
-            </a:r>
-          </a:p>
-        </p:txBody>
-      </p:sp>
-      <p:sp>
-        <p:nvSpPr>
-          <p:cNvPr id="35" name="TextBox 34"/>
-          <p:cNvSpPr txBox="1"/>
-          <p:nvPr/>
-        </p:nvSpPr>
-        <p:spPr>
-          <a:xfrm>
-            <a:off x="2084831" y="5129784"/>
-            <a:ext cx="8823960" cy="219456"/>
-          </a:xfrm>
-          <a:prstGeom prst="rect">
-            <a:avLst/>
-          </a:prstGeom>
-          <a:noFill/>
-        </p:spPr>
-        <p:txBody>
-          <a:bodyPr wrap="square" lIns="18288" rIns="18288" tIns="18288" bIns="18288" anchor="t">
-            <a:spAutoFit/>
-          </a:bodyPr>
-          <a:lstStyle/>
-          <a:p>
-            <a:pPr algn="l"/>
-            <a:r>
-              <a:rPr sz="1220" b="0">
-                <a:solidFill>
-                  <a:srgbClr val="667381"/>
-                </a:solidFill>
-                <a:latin typeface="Microsoft YaHei"/>
-              </a:rPr>
-              <a:t>已经提升 planner / robot success；Depth4ToM-FT 与 TransCG full test 仍未完成。</a:t>
-            </a:r>
-          </a:p>
-        </p:txBody>
-      </p:sp>
-      <p:sp>
-        <p:nvSpPr>
-          <p:cNvPr id="36" name="TextBox 35"/>
+              <a:t>多层深度能更完整地描述透明物体；是否让机器人抓得更稳，还需要下一步实验。</a:t>
+            </a:r>
+          </a:p>
+        </p:txBody>
+      </p:sp>
+      <p:sp>
+        <p:nvSpPr>
+          <p:cNvPr id="44" name="TextBox 43"/>
           <p:cNvSpPr txBox="1"/>
           <p:nvPr/>
         </p:nvSpPr>
@@ -9651,7 +9991,7 @@
                 </a:solidFill>
                 <a:latin typeface="Microsoft YaHei"/>
               </a:rPr>
-              <a:t>本地完整运行：Booster 228、LayeredDepth validation 300、TablewareNet test 100 scenes。</a:t>
+              <a:t>所有数字都来自本地完整运行；未完成的实验不提前写成结论。</a:t>
             </a:r>
           </a:p>
         </p:txBody>
@@ -9747,7 +10087,7 @@
                 </a:solidFill>
                 <a:latin typeface="Microsoft YaHei"/>
               </a:rPr>
-              <a:t>下一步：先证明规划收益，再训练新 Head</a:t>
+              <a:t>下一步：证明“多层深度是否真的更好抓”</a:t>
             </a:r>
           </a:p>
         </p:txBody>
@@ -9789,24 +10129,59 @@
       </p:cxnSp>
       <p:sp>
         <p:nvSpPr>
-          <p:cNvPr id="5" name="Oval 4"/>
+          <p:cNvPr id="5" name="TextBox 4"/>
+          <p:cNvSpPr txBox="1"/>
+          <p:nvPr/>
+        </p:nvSpPr>
+        <p:spPr>
+          <a:xfrm>
+            <a:off x="603504" y="1069848"/>
+            <a:ext cx="10424160" cy="228600"/>
+          </a:xfrm>
+          <a:prstGeom prst="rect">
+            <a:avLst/>
+          </a:prstGeom>
+          <a:noFill/>
+        </p:spPr>
+        <p:txBody>
+          <a:bodyPr wrap="square" lIns="18288" rIns="18288" tIns="18288" bIns="18288" anchor="t">
+            <a:spAutoFit/>
+          </a:bodyPr>
+          <a:lstStyle/>
+          <a:p>
+            <a:pPr algn="l"/>
+            <a:r>
+              <a:rPr sz="1320" b="0">
+                <a:solidFill>
+                  <a:srgbClr val="667381"/>
+                </a:solidFill>
+                <a:latin typeface="Microsoft YaHei"/>
+              </a:rPr>
+              <a:t>保持物体、物体区域和抓取规划器完全相同，只改变输入的几何信息。</a:t>
+            </a:r>
+          </a:p>
+        </p:txBody>
+      </p:sp>
+      <p:sp>
+        <p:nvSpPr>
+          <p:cNvPr id="6" name="Rounded Rectangle 5"/>
           <p:cNvSpPr/>
           <p:nvPr/>
         </p:nvSpPr>
         <p:spPr>
           <a:xfrm>
-            <a:off x="1563624" y="1463040"/>
-            <a:ext cx="475488" cy="475488"/>
-          </a:xfrm>
-          <a:prstGeom prst="ellipse">
+            <a:off x="960120" y="1517904"/>
+            <a:ext cx="10268712" cy="630936"/>
+          </a:xfrm>
+          <a:prstGeom prst="roundRect">
             <a:avLst/>
           </a:prstGeom>
           <a:solidFill>
-            <a:srgbClr val="0F766E"/>
+            <a:srgbClr val="EAF6F4"/>
           </a:solidFill>
-          <a:ln>
+          <a:ln w="10160">
             <a:solidFill>
-              <a:srgbClr val="0F766E"/>
+              <a:srgbClr val="EAF6F4"/>
             </a:solidFill>
           </a:ln>
         </p:spPr>
@@ -9834,154 +10209,245 @@
       </p:sp>
       <p:sp>
         <p:nvSpPr>
-          <p:cNvPr id="6" name="TextBox 5"/>
-          <p:cNvSpPr txBox="1"/>
-          <p:nvPr/>
-        </p:nvSpPr>
-        <p:spPr>
-          <a:xfrm>
-            <a:off x="1563624" y="1600931"/>
-            <a:ext cx="475488" cy="142646"/>
-          </a:xfrm>
-          <a:prstGeom prst="rect">
-            <a:avLst/>
-          </a:prstGeom>
-          <a:noFill/>
-        </p:spPr>
-        <p:txBody>
-          <a:bodyPr wrap="square" lIns="18288" rIns="18288" tIns="18288" bIns="18288" anchor="t">
-            <a:spAutoFit/>
-          </a:bodyPr>
-          <a:lstStyle/>
-          <a:p>
-            <a:pPr algn="ctr"/>
-            <a:r>
-              <a:rPr sz="1000" b="1">
-                <a:solidFill>
-                  <a:srgbClr val="FFFFFF"/>
-                </a:solidFill>
-                <a:latin typeface="Microsoft YaHei"/>
-              </a:rPr>
-              <a:t>1</a:t>
-            </a:r>
-          </a:p>
-        </p:txBody>
-      </p:sp>
-      <p:cxnSp>
-        <p:nvCxnSpPr>
-          <p:cNvPr id="7" name="Connector 6"/>
-          <p:cNvCxnSpPr/>
-          <p:nvPr/>
-        </p:nvCxnSpPr>
-        <p:spPr>
-          <a:xfrm>
-            <a:off x="2039112" y="1700784"/>
-            <a:ext cx="1380744" cy="0"/>
-          </a:xfrm>
-          <a:prstGeom prst="line">
-            <a:avLst/>
-          </a:prstGeom>
-          <a:ln w="19050">
+          <p:cNvPr id="7" name="TextBox 6"/>
+          <p:cNvSpPr txBox="1"/>
+          <p:nvPr/>
+        </p:nvSpPr>
+        <p:spPr>
+          <a:xfrm>
+            <a:off x="1188720" y="1719072"/>
+            <a:ext cx="9811512" cy="228600"/>
+          </a:xfrm>
+          <a:prstGeom prst="rect">
+            <a:avLst/>
+          </a:prstGeom>
+          <a:noFill/>
+        </p:spPr>
+        <p:txBody>
+          <a:bodyPr wrap="square" lIns="18288" rIns="18288" tIns="18288" bIns="18288" anchor="t">
+            <a:spAutoFit/>
+          </a:bodyPr>
+          <a:lstStyle/>
+          <a:p>
+            <a:pPr algn="ctr"/>
+            <a:r>
+              <a:rPr sz="1420" b="1">
+                <a:solidFill>
+                  <a:srgbClr val="0F766E"/>
+                </a:solidFill>
+                <a:latin typeface="Microsoft YaHei"/>
+              </a:rPr>
+              <a:t>核心问题：只知道最前表面，与知道前后 / 内外表面相比，哪一种抓取错误更少？</a:t>
+            </a:r>
+          </a:p>
+        </p:txBody>
+      </p:sp>
+      <p:sp>
+        <p:nvSpPr>
+          <p:cNvPr id="8" name="Rounded Rectangle 7"/>
+          <p:cNvSpPr/>
+          <p:nvPr/>
+        </p:nvSpPr>
+        <p:spPr>
+          <a:xfrm>
+            <a:off x="676656" y="2532888"/>
+            <a:ext cx="3447288" cy="2075688"/>
+          </a:xfrm>
+          <a:prstGeom prst="roundRect">
+            <a:avLst/>
+          </a:prstGeom>
+          <a:solidFill>
+            <a:srgbClr val="FFFFFF"/>
+          </a:solidFill>
+          <a:ln w="10160">
             <a:solidFill>
               <a:srgbClr val="DDE3E8"/>
             </a:solidFill>
           </a:ln>
         </p:spPr>
         <p:style>
-          <a:lnRef idx="2">
+          <a:lnRef idx="1">
             <a:schemeClr val="accent1"/>
           </a:lnRef>
-          <a:fillRef idx="0">
+          <a:fillRef idx="3">
             <a:schemeClr val="accent1"/>
           </a:fillRef>
-          <a:effectRef idx="1">
+          <a:effectRef idx="2">
             <a:schemeClr val="accent1"/>
           </a:effectRef>
           <a:fontRef idx="minor">
-            <a:schemeClr val="tx1"/>
+            <a:schemeClr val="lt1"/>
           </a:fontRef>
         </p:style>
-      </p:cxnSp>
-      <p:sp>
-        <p:nvSpPr>
-          <p:cNvPr id="8" name="TextBox 7"/>
-          <p:cNvSpPr txBox="1"/>
-          <p:nvPr/>
-        </p:nvSpPr>
-        <p:spPr>
-          <a:xfrm>
-            <a:off x="658368" y="2221992"/>
-            <a:ext cx="2304288" cy="384048"/>
-          </a:xfrm>
-          <a:prstGeom prst="rect">
-            <a:avLst/>
-          </a:prstGeom>
-          <a:noFill/>
-        </p:spPr>
-        <p:txBody>
-          <a:bodyPr wrap="square" lIns="18288" rIns="18288" tIns="18288" bIns="18288" anchor="t">
-            <a:spAutoFit/>
-          </a:bodyPr>
-          <a:lstStyle/>
-          <a:p>
-            <a:pPr algn="ctr"/>
-            <a:r>
-              <a:rPr sz="1300" b="1">
+        <p:txBody>
+          <a:bodyPr rtlCol="0" anchor="ctr"/>
+          <a:lstStyle/>
+          <a:p>
+            <a:pPr algn="ctr"/>
+          </a:p>
+        </p:txBody>
+      </p:sp>
+      <p:sp>
+        <p:nvSpPr>
+          <p:cNvPr id="9" name="Oval 8"/>
+          <p:cNvSpPr/>
+          <p:nvPr/>
+        </p:nvSpPr>
+        <p:spPr>
+          <a:xfrm>
+            <a:off x="877824" y="2761488"/>
+            <a:ext cx="402336" cy="402336"/>
+          </a:xfrm>
+          <a:prstGeom prst="ellipse">
+            <a:avLst/>
+          </a:prstGeom>
+          <a:solidFill>
+            <a:srgbClr val="2563EB"/>
+          </a:solidFill>
+          <a:ln>
+            <a:solidFill>
+              <a:srgbClr val="2563EB"/>
+            </a:solidFill>
+          </a:ln>
+        </p:spPr>
+        <p:style>
+          <a:lnRef idx="1">
+            <a:schemeClr val="accent1"/>
+          </a:lnRef>
+          <a:fillRef idx="3">
+            <a:schemeClr val="accent1"/>
+          </a:fillRef>
+          <a:effectRef idx="2">
+            <a:schemeClr val="accent1"/>
+          </a:effectRef>
+          <a:fontRef idx="minor">
+            <a:schemeClr val="lt1"/>
+          </a:fontRef>
+        </p:style>
+        <p:txBody>
+          <a:bodyPr rtlCol="0" anchor="ctr"/>
+          <a:lstStyle/>
+          <a:p>
+            <a:pPr algn="ctr"/>
+          </a:p>
+        </p:txBody>
+      </p:sp>
+      <p:sp>
+        <p:nvSpPr>
+          <p:cNvPr id="10" name="TextBox 9"/>
+          <p:cNvSpPr txBox="1"/>
+          <p:nvPr/>
+        </p:nvSpPr>
+        <p:spPr>
+          <a:xfrm>
+            <a:off x="877824" y="2878165"/>
+            <a:ext cx="402336" cy="120700"/>
+          </a:xfrm>
+          <a:prstGeom prst="rect">
+            <a:avLst/>
+          </a:prstGeom>
+          <a:noFill/>
+        </p:spPr>
+        <p:txBody>
+          <a:bodyPr wrap="square" lIns="18288" rIns="18288" tIns="18288" bIns="18288" anchor="t">
+            <a:spAutoFit/>
+          </a:bodyPr>
+          <a:lstStyle/>
+          <a:p>
+            <a:pPr algn="ctr"/>
+            <a:r>
+              <a:rPr sz="1000" b="1">
+                <a:solidFill>
+                  <a:srgbClr val="FFFFFF"/>
+                </a:solidFill>
+                <a:latin typeface="Microsoft YaHei"/>
+              </a:rPr>
+              <a:t>1</a:t>
+            </a:r>
+          </a:p>
+        </p:txBody>
+      </p:sp>
+      <p:sp>
+        <p:nvSpPr>
+          <p:cNvPr id="11" name="TextBox 10"/>
+          <p:cNvSpPr txBox="1"/>
+          <p:nvPr/>
+        </p:nvSpPr>
+        <p:spPr>
+          <a:xfrm>
+            <a:off x="1426464" y="2798064"/>
+            <a:ext cx="2395728" cy="228600"/>
+          </a:xfrm>
+          <a:prstGeom prst="rect">
+            <a:avLst/>
+          </a:prstGeom>
+          <a:noFill/>
+        </p:spPr>
+        <p:txBody>
+          <a:bodyPr wrap="square" lIns="18288" rIns="18288" tIns="18288" bIns="18288" anchor="t">
+            <a:spAutoFit/>
+          </a:bodyPr>
+          <a:lstStyle/>
+          <a:p>
+            <a:pPr algn="l"/>
+            <a:r>
+              <a:rPr sz="1400" b="1">
                 <a:solidFill>
                   <a:srgbClr val="172331"/>
                 </a:solidFill>
                 <a:latin typeface="Microsoft YaHei"/>
               </a:rPr>
-              <a:t>Planner oracle</a:t>
-            </a:r>
-          </a:p>
-        </p:txBody>
-      </p:sp>
-      <p:sp>
-        <p:nvSpPr>
-          <p:cNvPr id="9" name="TextBox 8"/>
-          <p:cNvSpPr txBox="1"/>
-          <p:nvPr/>
-        </p:nvSpPr>
-        <p:spPr>
-          <a:xfrm>
-            <a:off x="658368" y="2788920"/>
-            <a:ext cx="2304288" cy="347472"/>
-          </a:xfrm>
-          <a:prstGeom prst="rect">
-            <a:avLst/>
-          </a:prstGeom>
-          <a:noFill/>
-        </p:spPr>
-        <p:txBody>
-          <a:bodyPr wrap="square" lIns="18288" rIns="18288" tIns="18288" bIns="18288" anchor="t">
-            <a:spAutoFit/>
-          </a:bodyPr>
-          <a:lstStyle/>
-          <a:p>
-            <a:pPr algn="ctr"/>
-            <a:r>
-              <a:rPr sz="1019" b="0">
+              <a:t>做公平对比</a:t>
+            </a:r>
+          </a:p>
+        </p:txBody>
+      </p:sp>
+      <p:sp>
+        <p:nvSpPr>
+          <p:cNvPr id="12" name="TextBox 11"/>
+          <p:cNvSpPr txBox="1"/>
+          <p:nvPr/>
+        </p:nvSpPr>
+        <p:spPr>
+          <a:xfrm>
+            <a:off x="950976" y="3291840"/>
+            <a:ext cx="2898648" cy="685800"/>
+          </a:xfrm>
+          <a:prstGeom prst="rect">
+            <a:avLst/>
+          </a:prstGeom>
+          <a:noFill/>
+        </p:spPr>
+        <p:txBody>
+          <a:bodyPr wrap="square" lIns="18288" rIns="18288" tIns="18288" bIns="18288" anchor="ctr">
+            <a:spAutoFit/>
+          </a:bodyPr>
+          <a:lstStyle/>
+          <a:p>
+            <a:pPr algn="ctr"/>
+            <a:r>
+              <a:rPr sz="1070" b="0">
                 <a:solidFill>
                   <a:srgbClr val="667381"/>
                 </a:solidFill>
                 <a:latin typeface="Microsoft YaHei"/>
               </a:rPr>
-              <a:t>同一 planner 下比较</a:t>
-            </a:r>
-          </a:p>
-        </p:txBody>
-      </p:sp>
-      <p:sp>
-        <p:nvSpPr>
-          <p:cNvPr id="10" name="Rounded Rectangle 9"/>
+              <a:t>方案 A：只给最前表面
+方案 B：给出完整多层界面</a:t>
+            </a:r>
+          </a:p>
+        </p:txBody>
+      </p:sp>
+      <p:sp>
+        <p:nvSpPr>
+          <p:cNvPr id="13" name="Rounded Rectangle 12"/>
           <p:cNvSpPr/>
           <p:nvPr/>
         </p:nvSpPr>
         <p:spPr>
           <a:xfrm>
-            <a:off x="749808" y="3419856"/>
-            <a:ext cx="2121408" cy="749808"/>
+            <a:off x="960120" y="4114800"/>
+            <a:ext cx="2880360" cy="310896"/>
           </a:xfrm>
           <a:prstGeom prst="roundRect">
             <a:avLst/>
@@ -10019,60 +10485,59 @@
       </p:sp>
       <p:sp>
         <p:nvSpPr>
-          <p:cNvPr id="11" name="TextBox 10"/>
-          <p:cNvSpPr txBox="1"/>
-          <p:nvPr/>
-        </p:nvSpPr>
-        <p:spPr>
-          <a:xfrm>
-            <a:off x="841247" y="3611880"/>
-            <a:ext cx="1938528" cy="347472"/>
-          </a:xfrm>
-          <a:prstGeom prst="rect">
-            <a:avLst/>
-          </a:prstGeom>
-          <a:noFill/>
-        </p:spPr>
-        <p:txBody>
-          <a:bodyPr wrap="square" lIns="18288" rIns="18288" tIns="18288" bIns="18288" anchor="t">
-            <a:spAutoFit/>
-          </a:bodyPr>
-          <a:lstStyle/>
-          <a:p>
-            <a:pPr algn="ctr"/>
-            <a:r>
-              <a:rPr sz="1030" b="1">
-                <a:solidFill>
-                  <a:srgbClr val="0F766E"/>
-                </a:solidFill>
-                <a:latin typeface="Microsoft YaHei"/>
-              </a:rPr>
-              <a:t>GT-front
-vs GT-events</a:t>
-            </a:r>
-          </a:p>
-        </p:txBody>
-      </p:sp>
-      <p:sp>
-        <p:nvSpPr>
-          <p:cNvPr id="12" name="Oval 11"/>
+          <p:cNvPr id="14" name="TextBox 13"/>
+          <p:cNvSpPr txBox="1"/>
+          <p:nvPr/>
+        </p:nvSpPr>
+        <p:spPr>
+          <a:xfrm>
+            <a:off x="1033271" y="4187952"/>
+            <a:ext cx="2734056" cy="164592"/>
+          </a:xfrm>
+          <a:prstGeom prst="rect">
+            <a:avLst/>
+          </a:prstGeom>
+          <a:noFill/>
+        </p:spPr>
+        <p:txBody>
+          <a:bodyPr wrap="square" lIns="18288" rIns="18288" tIns="18288" bIns="18288" anchor="t">
+            <a:spAutoFit/>
+          </a:bodyPr>
+          <a:lstStyle/>
+          <a:p>
+            <a:pPr algn="ctr"/>
+            <a:r>
+              <a:rPr sz="869" b="1">
+                <a:solidFill>
+                  <a:srgbClr val="2563EB"/>
+                </a:solidFill>
+                <a:latin typeface="Microsoft YaHei"/>
+              </a:rPr>
+              <a:t>其余条件全部相同</a:t>
+            </a:r>
+          </a:p>
+        </p:txBody>
+      </p:sp>
+      <p:sp>
+        <p:nvSpPr>
+          <p:cNvPr id="15" name="Rounded Rectangle 14"/>
           <p:cNvSpPr/>
           <p:nvPr/>
         </p:nvSpPr>
         <p:spPr>
           <a:xfrm>
-            <a:off x="4398264" y="1463040"/>
-            <a:ext cx="475488" cy="475488"/>
-          </a:xfrm>
-          <a:prstGeom prst="ellipse">
+            <a:off x="4498848" y="2532888"/>
+            <a:ext cx="3447288" cy="2075688"/>
+          </a:xfrm>
+          <a:prstGeom prst="roundRect">
             <a:avLst/>
           </a:prstGeom>
           <a:solidFill>
-            <a:srgbClr val="2563EB"/>
+            <a:srgbClr val="FFFFFF"/>
           </a:solidFill>
-          <a:ln>
+          <a:ln w="10160">
             <a:solidFill>
-              <a:srgbClr val="2563EB"/>
+              <a:srgbClr val="DDE3E8"/>
             </a:solidFill>
           </a:ln>
         </p:spPr>
@@ -10100,154 +10565,166 @@
       </p:sp>
       <p:sp>
         <p:nvSpPr>
-          <p:cNvPr id="13" name="TextBox 12"/>
-          <p:cNvSpPr txBox="1"/>
-          <p:nvPr/>
-        </p:nvSpPr>
-        <p:spPr>
-          <a:xfrm>
-            <a:off x="4398264" y="1600931"/>
-            <a:ext cx="475488" cy="142646"/>
-          </a:xfrm>
-          <a:prstGeom prst="rect">
-            <a:avLst/>
-          </a:prstGeom>
-          <a:noFill/>
-        </p:spPr>
-        <p:txBody>
-          <a:bodyPr wrap="square" lIns="18288" rIns="18288" tIns="18288" bIns="18288" anchor="t">
-            <a:spAutoFit/>
-          </a:bodyPr>
-          <a:lstStyle/>
-          <a:p>
-            <a:pPr algn="ctr"/>
-            <a:r>
-              <a:rPr sz="1000" b="1">
-                <a:solidFill>
-                  <a:srgbClr val="FFFFFF"/>
-                </a:solidFill>
-                <a:latin typeface="Microsoft YaHei"/>
-              </a:rPr>
-              <a:t>2</a:t>
-            </a:r>
-          </a:p>
-        </p:txBody>
-      </p:sp>
-      <p:cxnSp>
-        <p:nvCxnSpPr>
-          <p:cNvPr id="14" name="Connector 13"/>
-          <p:cNvCxnSpPr/>
-          <p:nvPr/>
-        </p:nvCxnSpPr>
-        <p:spPr>
-          <a:xfrm>
-            <a:off x="4873752" y="1700784"/>
-            <a:ext cx="1380744" cy="0"/>
-          </a:xfrm>
-          <a:prstGeom prst="line">
-            <a:avLst/>
-          </a:prstGeom>
-          <a:ln w="19050">
+          <p:cNvPr id="16" name="Oval 15"/>
+          <p:cNvSpPr/>
+          <p:nvPr/>
+        </p:nvSpPr>
+        <p:spPr>
+          <a:xfrm>
+            <a:off x="4700016" y="2761488"/>
+            <a:ext cx="402336" cy="402336"/>
+          </a:xfrm>
+          <a:prstGeom prst="ellipse">
+            <a:avLst/>
+          </a:prstGeom>
+          <a:solidFill>
+            <a:srgbClr val="C46B16"/>
+          </a:solidFill>
+          <a:ln>
             <a:solidFill>
-              <a:srgbClr val="DDE3E8"/>
+              <a:srgbClr val="C46B16"/>
             </a:solidFill>
           </a:ln>
         </p:spPr>
         <p:style>
-          <a:lnRef idx="2">
+          <a:lnRef idx="1">
             <a:schemeClr val="accent1"/>
           </a:lnRef>
-          <a:fillRef idx="0">
+          <a:fillRef idx="3">
             <a:schemeClr val="accent1"/>
           </a:fillRef>
-          <a:effectRef idx="1">
+          <a:effectRef idx="2">
             <a:schemeClr val="accent1"/>
           </a:effectRef>
           <a:fontRef idx="minor">
-            <a:schemeClr val="tx1"/>
+            <a:schemeClr val="lt1"/>
           </a:fontRef>
         </p:style>
-      </p:cxnSp>
-      <p:sp>
-        <p:nvSpPr>
-          <p:cNvPr id="15" name="TextBox 14"/>
-          <p:cNvSpPr txBox="1"/>
-          <p:nvPr/>
-        </p:nvSpPr>
-        <p:spPr>
-          <a:xfrm>
-            <a:off x="3493008" y="2221992"/>
-            <a:ext cx="2304288" cy="384048"/>
-          </a:xfrm>
-          <a:prstGeom prst="rect">
-            <a:avLst/>
-          </a:prstGeom>
-          <a:noFill/>
-        </p:spPr>
-        <p:txBody>
-          <a:bodyPr wrap="square" lIns="18288" rIns="18288" tIns="18288" bIns="18288" anchor="t">
-            <a:spAutoFit/>
-          </a:bodyPr>
-          <a:lstStyle/>
-          <a:p>
-            <a:pPr algn="ctr"/>
-            <a:r>
-              <a:rPr sz="1300" b="1">
+        <p:txBody>
+          <a:bodyPr rtlCol="0" anchor="ctr"/>
+          <a:lstStyle/>
+          <a:p>
+            <a:pPr algn="ctr"/>
+          </a:p>
+        </p:txBody>
+      </p:sp>
+      <p:sp>
+        <p:nvSpPr>
+          <p:cNvPr id="17" name="TextBox 16"/>
+          <p:cNvSpPr txBox="1"/>
+          <p:nvPr/>
+        </p:nvSpPr>
+        <p:spPr>
+          <a:xfrm>
+            <a:off x="4700016" y="2878165"/>
+            <a:ext cx="402336" cy="120700"/>
+          </a:xfrm>
+          <a:prstGeom prst="rect">
+            <a:avLst/>
+          </a:prstGeom>
+          <a:noFill/>
+        </p:spPr>
+        <p:txBody>
+          <a:bodyPr wrap="square" lIns="18288" rIns="18288" tIns="18288" bIns="18288" anchor="t">
+            <a:spAutoFit/>
+          </a:bodyPr>
+          <a:lstStyle/>
+          <a:p>
+            <a:pPr algn="ctr"/>
+            <a:r>
+              <a:rPr sz="1000" b="1">
+                <a:solidFill>
+                  <a:srgbClr val="FFFFFF"/>
+                </a:solidFill>
+                <a:latin typeface="Microsoft YaHei"/>
+              </a:rPr>
+              <a:t>2</a:t>
+            </a:r>
+          </a:p>
+        </p:txBody>
+      </p:sp>
+      <p:sp>
+        <p:nvSpPr>
+          <p:cNvPr id="18" name="TextBox 17"/>
+          <p:cNvSpPr txBox="1"/>
+          <p:nvPr/>
+        </p:nvSpPr>
+        <p:spPr>
+          <a:xfrm>
+            <a:off x="5248656" y="2798064"/>
+            <a:ext cx="2395728" cy="228600"/>
+          </a:xfrm>
+          <a:prstGeom prst="rect">
+            <a:avLst/>
+          </a:prstGeom>
+          <a:noFill/>
+        </p:spPr>
+        <p:txBody>
+          <a:bodyPr wrap="square" lIns="18288" rIns="18288" tIns="18288" bIns="18288" anchor="t">
+            <a:spAutoFit/>
+          </a:bodyPr>
+          <a:lstStyle/>
+          <a:p>
+            <a:pPr algn="l"/>
+            <a:r>
+              <a:rPr sz="1400" b="1">
                 <a:solidFill>
                   <a:srgbClr val="172331"/>
                 </a:solidFill>
                 <a:latin typeface="Microsoft YaHei"/>
               </a:rPr>
-              <a:t>补齐 native baselines</a:t>
-            </a:r>
-          </a:p>
-        </p:txBody>
-      </p:sp>
-      <p:sp>
-        <p:nvSpPr>
-          <p:cNvPr id="16" name="TextBox 15"/>
-          <p:cNvSpPr txBox="1"/>
-          <p:nvPr/>
-        </p:nvSpPr>
-        <p:spPr>
-          <a:xfrm>
-            <a:off x="3493008" y="2788920"/>
-            <a:ext cx="2304288" cy="347472"/>
-          </a:xfrm>
-          <a:prstGeom prst="rect">
-            <a:avLst/>
-          </a:prstGeom>
-          <a:noFill/>
-        </p:spPr>
-        <p:txBody>
-          <a:bodyPr wrap="square" lIns="18288" rIns="18288" tIns="18288" bIns="18288" anchor="t">
-            <a:spAutoFit/>
-          </a:bodyPr>
-          <a:lstStyle/>
-          <a:p>
-            <a:pPr algn="ctr"/>
-            <a:r>
-              <a:rPr sz="1019" b="0">
+              <a:t>统计三类错误</a:t>
+            </a:r>
+          </a:p>
+        </p:txBody>
+      </p:sp>
+      <p:sp>
+        <p:nvSpPr>
+          <p:cNvPr id="19" name="TextBox 18"/>
+          <p:cNvSpPr txBox="1"/>
+          <p:nvPr/>
+        </p:nvSpPr>
+        <p:spPr>
+          <a:xfrm>
+            <a:off x="4773168" y="3291840"/>
+            <a:ext cx="2898648" cy="685800"/>
+          </a:xfrm>
+          <a:prstGeom prst="rect">
+            <a:avLst/>
+          </a:prstGeom>
+          <a:noFill/>
+        </p:spPr>
+        <p:txBody>
+          <a:bodyPr wrap="square" lIns="18288" rIns="18288" tIns="18288" bIns="18288" anchor="ctr">
+            <a:spAutoFit/>
+          </a:bodyPr>
+          <a:lstStyle/>
+          <a:p>
+            <a:pPr algn="ctr"/>
+            <a:r>
+              <a:rPr sz="1070" b="0">
                 <a:solidFill>
                   <a:srgbClr val="667381"/>
                 </a:solidFill>
                 <a:latin typeface="Microsoft YaHei"/>
               </a:rPr>
-              <a:t>完成 TransCG 余下 12 scenes</a:t>
-            </a:r>
-          </a:p>
-        </p:txBody>
-      </p:sp>
-      <p:sp>
-        <p:nvSpPr>
-          <p:cNvPr id="17" name="Rounded Rectangle 16"/>
+              <a:t>① 穿过物体外壁
+② 把空腔当成实心
+③ 抓取位姿碰撞或不可达</a:t>
+            </a:r>
+          </a:p>
+        </p:txBody>
+      </p:sp>
+      <p:sp>
+        <p:nvSpPr>
+          <p:cNvPr id="20" name="Rounded Rectangle 19"/>
           <p:cNvSpPr/>
           <p:nvPr/>
         </p:nvSpPr>
         <p:spPr>
           <a:xfrm>
-            <a:off x="3584448" y="3419856"/>
-            <a:ext cx="2121408" cy="749808"/>
+            <a:off x="4782312" y="4114800"/>
+            <a:ext cx="2880360" cy="310896"/>
           </a:xfrm>
           <a:prstGeom prst="roundRect">
             <a:avLst/>
@@ -10285,60 +10762,59 @@
       </p:sp>
       <p:sp>
         <p:nvSpPr>
-          <p:cNvPr id="18" name="TextBox 17"/>
-          <p:cNvSpPr txBox="1"/>
-          <p:nvPr/>
-        </p:nvSpPr>
-        <p:spPr>
-          <a:xfrm>
-            <a:off x="3675888" y="3611880"/>
-            <a:ext cx="1938528" cy="347472"/>
-          </a:xfrm>
-          <a:prstGeom prst="rect">
-            <a:avLst/>
-          </a:prstGeom>
-          <a:noFill/>
-        </p:spPr>
-        <p:txBody>
-          <a:bodyPr wrap="square" lIns="18288" rIns="18288" tIns="18288" bIns="18288" anchor="t">
-            <a:spAutoFit/>
-          </a:bodyPr>
-          <a:lstStyle/>
-          <a:p>
-            <a:pPr algn="ctr"/>
-            <a:r>
-              <a:rPr sz="1030" b="1">
-                <a:solidFill>
-                  <a:srgbClr val="2563EB"/>
-                </a:solidFill>
-                <a:latin typeface="Microsoft YaHei"/>
-              </a:rPr>
-              <a:t>DFNet + ReMake
-23,524 samples</a:t>
-            </a:r>
-          </a:p>
-        </p:txBody>
-      </p:sp>
-      <p:sp>
-        <p:nvSpPr>
-          <p:cNvPr id="19" name="Oval 18"/>
+          <p:cNvPr id="21" name="TextBox 20"/>
+          <p:cNvSpPr txBox="1"/>
+          <p:nvPr/>
+        </p:nvSpPr>
+        <p:spPr>
+          <a:xfrm>
+            <a:off x="4855464" y="4187952"/>
+            <a:ext cx="2734056" cy="164592"/>
+          </a:xfrm>
+          <a:prstGeom prst="rect">
+            <a:avLst/>
+          </a:prstGeom>
+          <a:noFill/>
+        </p:spPr>
+        <p:txBody>
+          <a:bodyPr wrap="square" lIns="18288" rIns="18288" tIns="18288" bIns="18288" anchor="t">
+            <a:spAutoFit/>
+          </a:bodyPr>
+          <a:lstStyle/>
+          <a:p>
+            <a:pPr algn="ctr"/>
+            <a:r>
+              <a:rPr sz="869" b="1">
+                <a:solidFill>
+                  <a:srgbClr val="C46B16"/>
+                </a:solidFill>
+                <a:latin typeface="Microsoft YaHei"/>
+              </a:rPr>
+              <a:t>重复实验，比较错误率和波动</a:t>
+            </a:r>
+          </a:p>
+        </p:txBody>
+      </p:sp>
+      <p:sp>
+        <p:nvSpPr>
+          <p:cNvPr id="22" name="Rounded Rectangle 21"/>
           <p:cNvSpPr/>
           <p:nvPr/>
         </p:nvSpPr>
         <p:spPr>
           <a:xfrm>
-            <a:off x="7232904" y="1463040"/>
-            <a:ext cx="475488" cy="475488"/>
-          </a:xfrm>
-          <a:prstGeom prst="ellipse">
+            <a:off x="8321040" y="2532888"/>
+            <a:ext cx="3447288" cy="2075688"/>
+          </a:xfrm>
+          <a:prstGeom prst="roundRect">
             <a:avLst/>
           </a:prstGeom>
           <a:solidFill>
-            <a:srgbClr val="C46B16"/>
+            <a:srgbClr val="FFFFFF"/>
           </a:solidFill>
-          <a:ln>
+          <a:ln w="10160">
             <a:solidFill>
-              <a:srgbClr val="C46B16"/>
+              <a:srgbClr val="DDE3E8"/>
             </a:solidFill>
           </a:ln>
         </p:spPr>
@@ -10366,154 +10842,165 @@
       </p:sp>
       <p:sp>
         <p:nvSpPr>
-          <p:cNvPr id="20" name="TextBox 19"/>
-          <p:cNvSpPr txBox="1"/>
-          <p:nvPr/>
-        </p:nvSpPr>
-        <p:spPr>
-          <a:xfrm>
-            <a:off x="7232904" y="1600931"/>
-            <a:ext cx="475488" cy="142646"/>
-          </a:xfrm>
-          <a:prstGeom prst="rect">
-            <a:avLst/>
-          </a:prstGeom>
-          <a:noFill/>
-        </p:spPr>
-        <p:txBody>
-          <a:bodyPr wrap="square" lIns="18288" rIns="18288" tIns="18288" bIns="18288" anchor="t">
-            <a:spAutoFit/>
-          </a:bodyPr>
-          <a:lstStyle/>
-          <a:p>
-            <a:pPr algn="ctr"/>
-            <a:r>
-              <a:rPr sz="1000" b="1">
-                <a:solidFill>
-                  <a:srgbClr val="FFFFFF"/>
-                </a:solidFill>
-                <a:latin typeface="Microsoft YaHei"/>
-              </a:rPr>
-              <a:t>3</a:t>
-            </a:r>
-          </a:p>
-        </p:txBody>
-      </p:sp>
-      <p:cxnSp>
-        <p:nvCxnSpPr>
-          <p:cNvPr id="21" name="Connector 20"/>
-          <p:cNvCxnSpPr/>
-          <p:nvPr/>
-        </p:nvCxnSpPr>
-        <p:spPr>
-          <a:xfrm>
-            <a:off x="7708392" y="1700784"/>
-            <a:ext cx="1380744" cy="0"/>
-          </a:xfrm>
-          <a:prstGeom prst="line">
-            <a:avLst/>
-          </a:prstGeom>
-          <a:ln w="19050">
+          <p:cNvPr id="23" name="Oval 22"/>
+          <p:cNvSpPr/>
+          <p:nvPr/>
+        </p:nvSpPr>
+        <p:spPr>
+          <a:xfrm>
+            <a:off x="8522208" y="2761488"/>
+            <a:ext cx="402336" cy="402336"/>
+          </a:xfrm>
+          <a:prstGeom prst="ellipse">
+            <a:avLst/>
+          </a:prstGeom>
+          <a:solidFill>
+            <a:srgbClr val="15805D"/>
+          </a:solidFill>
+          <a:ln>
             <a:solidFill>
-              <a:srgbClr val="DDE3E8"/>
+              <a:srgbClr val="15805D"/>
             </a:solidFill>
           </a:ln>
         </p:spPr>
         <p:style>
-          <a:lnRef idx="2">
+          <a:lnRef idx="1">
             <a:schemeClr val="accent1"/>
           </a:lnRef>
-          <a:fillRef idx="0">
+          <a:fillRef idx="3">
             <a:schemeClr val="accent1"/>
           </a:fillRef>
-          <a:effectRef idx="1">
+          <a:effectRef idx="2">
             <a:schemeClr val="accent1"/>
           </a:effectRef>
           <a:fontRef idx="minor">
-            <a:schemeClr val="tx1"/>
+            <a:schemeClr val="lt1"/>
           </a:fontRef>
         </p:style>
-      </p:cxnSp>
-      <p:sp>
-        <p:nvSpPr>
-          <p:cNvPr id="22" name="TextBox 21"/>
-          <p:cNvSpPr txBox="1"/>
-          <p:nvPr/>
-        </p:nvSpPr>
-        <p:spPr>
-          <a:xfrm>
-            <a:off x="6327648" y="2221992"/>
-            <a:ext cx="2304288" cy="384048"/>
-          </a:xfrm>
-          <a:prstGeom prst="rect">
-            <a:avLst/>
-          </a:prstGeom>
-          <a:noFill/>
-        </p:spPr>
-        <p:txBody>
-          <a:bodyPr wrap="square" lIns="18288" rIns="18288" tIns="18288" bIns="18288" anchor="t">
-            <a:spAutoFit/>
-          </a:bodyPr>
-          <a:lstStyle/>
-          <a:p>
-            <a:pPr algn="ctr"/>
-            <a:r>
-              <a:rPr sz="1300" b="1">
+        <p:txBody>
+          <a:bodyPr rtlCol="0" anchor="ctr"/>
+          <a:lstStyle/>
+          <a:p>
+            <a:pPr algn="ctr"/>
+          </a:p>
+        </p:txBody>
+      </p:sp>
+      <p:sp>
+        <p:nvSpPr>
+          <p:cNvPr id="24" name="TextBox 23"/>
+          <p:cNvSpPr txBox="1"/>
+          <p:nvPr/>
+        </p:nvSpPr>
+        <p:spPr>
+          <a:xfrm>
+            <a:off x="8522208" y="2878165"/>
+            <a:ext cx="402336" cy="120700"/>
+          </a:xfrm>
+          <a:prstGeom prst="rect">
+            <a:avLst/>
+          </a:prstGeom>
+          <a:noFill/>
+        </p:spPr>
+        <p:txBody>
+          <a:bodyPr wrap="square" lIns="18288" rIns="18288" tIns="18288" bIns="18288" anchor="t">
+            <a:spAutoFit/>
+          </a:bodyPr>
+          <a:lstStyle/>
+          <a:p>
+            <a:pPr algn="ctr"/>
+            <a:r>
+              <a:rPr sz="1000" b="1">
+                <a:solidFill>
+                  <a:srgbClr val="FFFFFF"/>
+                </a:solidFill>
+                <a:latin typeface="Microsoft YaHei"/>
+              </a:rPr>
+              <a:t>3</a:t>
+            </a:r>
+          </a:p>
+        </p:txBody>
+      </p:sp>
+      <p:sp>
+        <p:nvSpPr>
+          <p:cNvPr id="25" name="TextBox 24"/>
+          <p:cNvSpPr txBox="1"/>
+          <p:nvPr/>
+        </p:nvSpPr>
+        <p:spPr>
+          <a:xfrm>
+            <a:off x="9070848" y="2798064"/>
+            <a:ext cx="2395728" cy="228600"/>
+          </a:xfrm>
+          <a:prstGeom prst="rect">
+            <a:avLst/>
+          </a:prstGeom>
+          <a:noFill/>
+        </p:spPr>
+        <p:txBody>
+          <a:bodyPr wrap="square" lIns="18288" rIns="18288" tIns="18288" bIns="18288" anchor="t">
+            <a:spAutoFit/>
+          </a:bodyPr>
+          <a:lstStyle/>
+          <a:p>
+            <a:pPr algn="l"/>
+            <a:r>
+              <a:rPr sz="1400" b="1">
                 <a:solidFill>
                   <a:srgbClr val="172331"/>
                 </a:solidFill>
                 <a:latin typeface="Microsoft YaHei"/>
               </a:rPr>
-              <a:t>统一 failure slice</a:t>
-            </a:r>
-          </a:p>
-        </p:txBody>
-      </p:sp>
-      <p:sp>
-        <p:nvSpPr>
-          <p:cNvPr id="23" name="TextBox 22"/>
-          <p:cNvSpPr txBox="1"/>
-          <p:nvPr/>
-        </p:nvSpPr>
-        <p:spPr>
-          <a:xfrm>
-            <a:off x="6327648" y="2788920"/>
-            <a:ext cx="2304288" cy="347472"/>
-          </a:xfrm>
-          <a:prstGeom prst="rect">
-            <a:avLst/>
-          </a:prstGeom>
-          <a:noFill/>
-        </p:spPr>
-        <p:txBody>
-          <a:bodyPr wrap="square" lIns="18288" rIns="18288" tIns="18288" bIns="18288" anchor="t">
-            <a:spAutoFit/>
-          </a:bodyPr>
-          <a:lstStyle/>
-          <a:p>
-            <a:pPr algn="ctr"/>
-            <a:r>
-              <a:rPr sz="1019" b="0">
+              <a:t>根据结果决定</a:t>
+            </a:r>
+          </a:p>
+        </p:txBody>
+      </p:sp>
+      <p:sp>
+        <p:nvSpPr>
+          <p:cNvPr id="26" name="TextBox 25"/>
+          <p:cNvSpPr txBox="1"/>
+          <p:nvPr/>
+        </p:nvSpPr>
+        <p:spPr>
+          <a:xfrm>
+            <a:off x="8595360" y="3291840"/>
+            <a:ext cx="2898648" cy="685800"/>
+          </a:xfrm>
+          <a:prstGeom prst="rect">
+            <a:avLst/>
+          </a:prstGeom>
+          <a:noFill/>
+        </p:spPr>
+        <p:txBody>
+          <a:bodyPr wrap="square" lIns="18288" rIns="18288" tIns="18288" bIns="18288" anchor="ctr">
+            <a:spAutoFit/>
+          </a:bodyPr>
+          <a:lstStyle/>
+          <a:p>
+            <a:pPr algn="ctr"/>
+            <a:r>
+              <a:rPr sz="1070" b="0">
                 <a:solidFill>
                   <a:srgbClr val="667381"/>
                 </a:solidFill>
                 <a:latin typeface="Microsoft YaHei"/>
               </a:rPr>
-              <a:t>按场景报告置信区间</a:t>
-            </a:r>
-          </a:p>
-        </p:txBody>
-      </p:sp>
-      <p:sp>
-        <p:nvSpPr>
-          <p:cNvPr id="24" name="Rounded Rectangle 23"/>
+              <a:t>错误明显减少：训练我们的多层模型
+没有减少：先修改规划器或评测</a:t>
+            </a:r>
+          </a:p>
+        </p:txBody>
+      </p:sp>
+      <p:sp>
+        <p:nvSpPr>
+          <p:cNvPr id="27" name="Rounded Rectangle 26"/>
           <p:cNvSpPr/>
           <p:nvPr/>
         </p:nvSpPr>
         <p:spPr>
           <a:xfrm>
-            <a:off x="6419088" y="3419856"/>
-            <a:ext cx="2121408" cy="749808"/>
+            <a:off x="8604504" y="4114800"/>
+            <a:ext cx="2880360" cy="310896"/>
           </a:xfrm>
           <a:prstGeom prst="roundRect">
             <a:avLst/>
@@ -10551,60 +11038,59 @@
       </p:sp>
       <p:sp>
         <p:nvSpPr>
-          <p:cNvPr id="25" name="TextBox 24"/>
-          <p:cNvSpPr txBox="1"/>
-          <p:nvPr/>
-        </p:nvSpPr>
-        <p:spPr>
-          <a:xfrm>
-            <a:off x="6510528" y="3611880"/>
-            <a:ext cx="1938528" cy="347472"/>
-          </a:xfrm>
-          <a:prstGeom prst="rect">
-            <a:avLst/>
-          </a:prstGeom>
-          <a:noFill/>
-        </p:spPr>
-        <p:txBody>
-          <a:bodyPr wrap="square" lIns="18288" rIns="18288" tIns="18288" bIns="18288" anchor="t">
-            <a:spAutoFit/>
-          </a:bodyPr>
-          <a:lstStyle/>
-          <a:p>
-            <a:pPr algn="ctr"/>
-            <a:r>
-              <a:rPr sz="1030" b="1">
-                <a:solidFill>
-                  <a:srgbClr val="C46B16"/>
-                </a:solidFill>
-                <a:latin typeface="Microsoft YaHei"/>
-              </a:rPr>
-              <a:t>穿壁 / 空腔 /
-遮挡 / mask</a:t>
-            </a:r>
-          </a:p>
-        </p:txBody>
-      </p:sp>
-      <p:sp>
-        <p:nvSpPr>
-          <p:cNvPr id="26" name="Oval 25"/>
+          <p:cNvPr id="28" name="TextBox 27"/>
+          <p:cNvSpPr txBox="1"/>
+          <p:nvPr/>
+        </p:nvSpPr>
+        <p:spPr>
+          <a:xfrm>
+            <a:off x="8677656" y="4187952"/>
+            <a:ext cx="2734056" cy="164592"/>
+          </a:xfrm>
+          <a:prstGeom prst="rect">
+            <a:avLst/>
+          </a:prstGeom>
+          <a:noFill/>
+        </p:spPr>
+        <p:txBody>
+          <a:bodyPr wrap="square" lIns="18288" rIns="18288" tIns="18288" bIns="18288" anchor="t">
+            <a:spAutoFit/>
+          </a:bodyPr>
+          <a:lstStyle/>
+          <a:p>
+            <a:pPr algn="ctr"/>
+            <a:r>
+              <a:rPr sz="869" b="1">
+                <a:solidFill>
+                  <a:srgbClr val="15805D"/>
+                </a:solidFill>
+                <a:latin typeface="Microsoft YaHei"/>
+              </a:rPr>
+              <a:t>不盲目堆模型</a:t>
+            </a:r>
+          </a:p>
+        </p:txBody>
+      </p:sp>
+      <p:sp>
+        <p:nvSpPr>
+          <p:cNvPr id="29" name="Rounded Rectangle 28"/>
           <p:cNvSpPr/>
           <p:nvPr/>
         </p:nvSpPr>
         <p:spPr>
           <a:xfrm>
-            <a:off x="10067544" y="1463040"/>
-            <a:ext cx="475488" cy="475488"/>
-          </a:xfrm>
-          <a:prstGeom prst="ellipse">
+            <a:off x="877824" y="4965192"/>
+            <a:ext cx="10433304" cy="585216"/>
+          </a:xfrm>
+          <a:prstGeom prst="roundRect">
             <a:avLst/>
           </a:prstGeom>
           <a:solidFill>
-            <a:srgbClr val="15805D"/>
+            <a:srgbClr val="EEF4FF"/>
           </a:solidFill>
-          <a:ln>
+          <a:ln w="10160">
             <a:solidFill>
-              <a:srgbClr val="15805D"/>
+              <a:srgbClr val="EEF4FF"/>
             </a:solidFill>
           </a:ln>
         </p:spPr>
@@ -10632,151 +11118,36 @@
       </p:sp>
       <p:sp>
         <p:nvSpPr>
-          <p:cNvPr id="27" name="TextBox 26"/>
-          <p:cNvSpPr txBox="1"/>
-          <p:nvPr/>
-        </p:nvSpPr>
-        <p:spPr>
-          <a:xfrm>
-            <a:off x="10067544" y="1600931"/>
-            <a:ext cx="475488" cy="142646"/>
-          </a:xfrm>
-          <a:prstGeom prst="rect">
-            <a:avLst/>
-          </a:prstGeom>
-          <a:noFill/>
-        </p:spPr>
-        <p:txBody>
-          <a:bodyPr wrap="square" lIns="18288" rIns="18288" tIns="18288" bIns="18288" anchor="t">
-            <a:spAutoFit/>
-          </a:bodyPr>
-          <a:lstStyle/>
-          <a:p>
-            <a:pPr algn="ctr"/>
-            <a:r>
-              <a:rPr sz="1000" b="1">
-                <a:solidFill>
-                  <a:srgbClr val="FFFFFF"/>
-                </a:solidFill>
-                <a:latin typeface="Microsoft YaHei"/>
-              </a:rPr>
-              <a:t>4</a:t>
-            </a:r>
-          </a:p>
-        </p:txBody>
-      </p:sp>
-      <p:sp>
-        <p:nvSpPr>
-          <p:cNvPr id="28" name="TextBox 27"/>
-          <p:cNvSpPr txBox="1"/>
-          <p:nvPr/>
-        </p:nvSpPr>
-        <p:spPr>
-          <a:xfrm>
-            <a:off x="9162288" y="2221992"/>
-            <a:ext cx="2304288" cy="384048"/>
-          </a:xfrm>
-          <a:prstGeom prst="rect">
-            <a:avLst/>
-          </a:prstGeom>
-          <a:noFill/>
-        </p:spPr>
-        <p:txBody>
-          <a:bodyPr wrap="square" lIns="18288" rIns="18288" tIns="18288" bIns="18288" anchor="t">
-            <a:spAutoFit/>
-          </a:bodyPr>
-          <a:lstStyle/>
-          <a:p>
-            <a:pPr algn="ctr"/>
-            <a:r>
-              <a:rPr sz="1300" b="1">
-                <a:solidFill>
-                  <a:srgbClr val="172331"/>
-                </a:solidFill>
-                <a:latin typeface="Microsoft YaHei"/>
-              </a:rPr>
-              <a:t>训练我们的 Head</a:t>
-            </a:r>
-          </a:p>
-        </p:txBody>
-      </p:sp>
-      <p:sp>
-        <p:nvSpPr>
-          <p:cNvPr id="29" name="TextBox 28"/>
-          <p:cNvSpPr txBox="1"/>
-          <p:nvPr/>
-        </p:nvSpPr>
-        <p:spPr>
-          <a:xfrm>
-            <a:off x="9162288" y="2788920"/>
-            <a:ext cx="2304288" cy="347472"/>
-          </a:xfrm>
-          <a:prstGeom prst="rect">
-            <a:avLst/>
-          </a:prstGeom>
-          <a:noFill/>
-        </p:spPr>
-        <p:txBody>
-          <a:bodyPr wrap="square" lIns="18288" rIns="18288" tIns="18288" bIns="18288" anchor="t">
-            <a:spAutoFit/>
-          </a:bodyPr>
-          <a:lstStyle/>
-          <a:p>
-            <a:pPr algn="ctr"/>
-            <a:r>
-              <a:rPr sz="1019" b="0">
-                <a:solidFill>
-                  <a:srgbClr val="667381"/>
-                </a:solidFill>
-                <a:latin typeface="Microsoft YaHei"/>
-              </a:rPr>
-              <a:t>仅在 Gate 1 成立后</a:t>
-            </a:r>
-          </a:p>
-        </p:txBody>
-      </p:sp>
-      <p:sp>
-        <p:nvSpPr>
-          <p:cNvPr id="30" name="Rounded Rectangle 29"/>
-          <p:cNvSpPr/>
-          <p:nvPr/>
-        </p:nvSpPr>
-        <p:spPr>
-          <a:xfrm>
-            <a:off x="9253728" y="3419856"/>
-            <a:ext cx="2121408" cy="749808"/>
-          </a:xfrm>
-          <a:prstGeom prst="roundRect">
-            <a:avLst/>
-          </a:prstGeom>
-          <a:solidFill>
-            <a:srgbClr val="F5F8FA"/>
-          </a:solidFill>
-          <a:ln w="10160">
-            <a:solidFill>
-              <a:srgbClr val="F5F8FA"/>
-            </a:solidFill>
-          </a:ln>
-        </p:spPr>
-        <p:style>
-          <a:lnRef idx="1">
-            <a:schemeClr val="accent1"/>
-          </a:lnRef>
-          <a:fillRef idx="3">
-            <a:schemeClr val="accent1"/>
-          </a:fillRef>
-          <a:effectRef idx="2">
-            <a:schemeClr val="accent1"/>
-          </a:effectRef>
-          <a:fontRef idx="minor">
-            <a:schemeClr val="lt1"/>
-          </a:fontRef>
-        </p:style>
-        <p:txBody>
-          <a:bodyPr rtlCol="0" anchor="ctr"/>
-          <a:lstStyle/>
-          <a:p>
-            <a:pPr algn="ctr"/>
+          <p:cNvPr id="30" name="TextBox 29"/>
+          <p:cNvSpPr txBox="1"/>
+          <p:nvPr/>
+        </p:nvSpPr>
+        <p:spPr>
+          <a:xfrm>
+            <a:off x="1143000" y="5148072"/>
+            <a:ext cx="9902952" cy="210312"/>
+          </a:xfrm>
+          <a:prstGeom prst="rect">
+            <a:avLst/>
+          </a:prstGeom>
+          <a:noFill/>
+        </p:spPr>
+        <p:txBody>
+          <a:bodyPr wrap="square" lIns="18288" rIns="18288" tIns="18288" bIns="18288" anchor="t">
+            <a:spAutoFit/>
+          </a:bodyPr>
+          <a:lstStyle/>
+          <a:p>
+            <a:pPr algn="ctr"/>
+            <a:r>
+              <a:rPr sz="1200" b="1">
+                <a:solidFill>
+                  <a:srgbClr val="2563EB"/>
+                </a:solidFill>
+                <a:latin typeface="Microsoft YaHei"/>
+              </a:rPr>
+              <a:t>同时补齐已有方法：TransCG 剩余 12 个场景，并完成 DFNet / ReMake 全量测试。</a:t>
+            </a:r>
           </a:p>
         </p:txBody>
       </p:sp>
@@ -10788,186 +11159,36 @@
         </p:nvSpPr>
         <p:spPr>
           <a:xfrm>
-            <a:off x="9345168" y="3611880"/>
-            <a:ext cx="1938528" cy="347472"/>
-          </a:xfrm>
-          <a:prstGeom prst="rect">
-            <a:avLst/>
-          </a:prstGeom>
-          <a:noFill/>
-        </p:spPr>
-        <p:txBody>
-          <a:bodyPr wrap="square" lIns="18288" rIns="18288" tIns="18288" bIns="18288" anchor="t">
-            <a:spAutoFit/>
-          </a:bodyPr>
-          <a:lstStyle/>
-          <a:p>
-            <a:pPr algn="ctr"/>
-            <a:r>
-              <a:rPr sz="1030" b="1">
-                <a:solidFill>
-                  <a:srgbClr val="15805D"/>
-                </a:solidFill>
-                <a:latin typeface="Microsoft YaHei"/>
-              </a:rPr>
-              <a:t>DepthHypothesisPack</a:t>
-            </a:r>
-          </a:p>
-        </p:txBody>
-      </p:sp>
-      <p:sp>
-        <p:nvSpPr>
-          <p:cNvPr id="32" name="Rounded Rectangle 31"/>
-          <p:cNvSpPr/>
-          <p:nvPr/>
-        </p:nvSpPr>
-        <p:spPr>
-          <a:xfrm>
-            <a:off x="1024128" y="4837176"/>
-            <a:ext cx="10131552" cy="713232"/>
-          </a:xfrm>
-          <a:prstGeom prst="roundRect">
-            <a:avLst/>
-          </a:prstGeom>
-          <a:solidFill>
-            <a:srgbClr val="EAF6F4"/>
-          </a:solidFill>
-          <a:ln w="10160">
-            <a:solidFill>
-              <a:srgbClr val="EAF6F4"/>
-            </a:solidFill>
-          </a:ln>
-        </p:spPr>
-        <p:style>
-          <a:lnRef idx="1">
-            <a:schemeClr val="accent1"/>
-          </a:lnRef>
-          <a:fillRef idx="3">
-            <a:schemeClr val="accent1"/>
-          </a:fillRef>
-          <a:effectRef idx="2">
-            <a:schemeClr val="accent1"/>
-          </a:effectRef>
-          <a:fontRef idx="minor">
-            <a:schemeClr val="lt1"/>
-          </a:fontRef>
-        </p:style>
-        <p:txBody>
-          <a:bodyPr rtlCol="0" anchor="ctr"/>
-          <a:lstStyle/>
-          <a:p>
-            <a:pPr algn="ctr"/>
-          </a:p>
-        </p:txBody>
-      </p:sp>
-      <p:sp>
-        <p:nvSpPr>
-          <p:cNvPr id="33" name="TextBox 32"/>
-          <p:cNvSpPr txBox="1"/>
-          <p:nvPr/>
-        </p:nvSpPr>
-        <p:spPr>
-          <a:xfrm>
-            <a:off x="1271016" y="5074920"/>
-            <a:ext cx="1243584" cy="182880"/>
-          </a:xfrm>
-          <a:prstGeom prst="rect">
-            <a:avLst/>
-          </a:prstGeom>
-          <a:noFill/>
-        </p:spPr>
-        <p:txBody>
-          <a:bodyPr wrap="square" lIns="18288" rIns="18288" tIns="18288" bIns="18288" anchor="t">
-            <a:spAutoFit/>
-          </a:bodyPr>
-          <a:lstStyle/>
-          <a:p>
-            <a:pPr algn="l"/>
-            <a:r>
-              <a:rPr sz="1200" b="1">
+            <a:off x="1591056" y="5907024"/>
+            <a:ext cx="9015984" cy="256032"/>
+          </a:xfrm>
+          <a:prstGeom prst="rect">
+            <a:avLst/>
+          </a:prstGeom>
+          <a:noFill/>
+        </p:spPr>
+        <p:txBody>
+          <a:bodyPr wrap="square" lIns="18288" rIns="18288" tIns="18288" bIns="18288" anchor="t">
+            <a:spAutoFit/>
+          </a:bodyPr>
+          <a:lstStyle/>
+          <a:p>
+            <a:pPr algn="ctr"/>
+            <a:r>
+              <a:rPr sz="1540" b="1">
                 <a:solidFill>
                   <a:srgbClr val="0F766E"/>
                 </a:solidFill>
                 <a:latin typeface="Microsoft YaHei"/>
               </a:rPr>
-              <a:t>Go / No-Go</a:t>
-            </a:r>
-          </a:p>
-        </p:txBody>
-      </p:sp>
-      <p:sp>
-        <p:nvSpPr>
-          <p:cNvPr id="34" name="TextBox 33"/>
-          <p:cNvSpPr txBox="1"/>
-          <p:nvPr/>
-        </p:nvSpPr>
-        <p:spPr>
-          <a:xfrm>
-            <a:off x="2414016" y="5038344"/>
-            <a:ext cx="8375904" cy="265176"/>
-          </a:xfrm>
-          <a:prstGeom prst="rect">
-            <a:avLst/>
-          </a:prstGeom>
-          <a:noFill/>
-        </p:spPr>
-        <p:txBody>
-          <a:bodyPr wrap="square" lIns="18288" rIns="18288" tIns="18288" bIns="18288" anchor="t">
-            <a:spAutoFit/>
-          </a:bodyPr>
-          <a:lstStyle/>
-          <a:p>
-            <a:pPr algn="l"/>
-            <a:r>
-              <a:rPr sz="1400" b="1">
-                <a:solidFill>
-                  <a:srgbClr val="172331"/>
-                </a:solidFill>
-                <a:latin typeface="Microsoft YaHei"/>
-              </a:rPr>
-              <a:t>若 GT-events 不能改善固定 planner，就先修 planner / benchmark，而不是继续堆模型。</a:t>
-            </a:r>
-          </a:p>
-        </p:txBody>
-      </p:sp>
-      <p:sp>
-        <p:nvSpPr>
-          <p:cNvPr id="35" name="TextBox 34"/>
-          <p:cNvSpPr txBox="1"/>
-          <p:nvPr/>
-        </p:nvSpPr>
-        <p:spPr>
-          <a:xfrm>
-            <a:off x="2084831" y="5925312"/>
-            <a:ext cx="8010144" cy="246888"/>
-          </a:xfrm>
-          <a:prstGeom prst="rect">
-            <a:avLst/>
-          </a:prstGeom>
-          <a:noFill/>
-        </p:spPr>
-        <p:txBody>
-          <a:bodyPr wrap="square" lIns="18288" rIns="18288" tIns="18288" bIns="18288" anchor="t">
-            <a:spAutoFit/>
-          </a:bodyPr>
-          <a:lstStyle/>
-          <a:p>
-            <a:pPr algn="ctr"/>
-            <a:r>
-              <a:rPr sz="1600" b="1">
-                <a:solidFill>
-                  <a:srgbClr val="0F766E"/>
-                </a:solidFill>
-                <a:latin typeface="Microsoft YaHei"/>
-              </a:rPr>
-              <a:t>我们真正要证明的是：多层几何 → 更少的抓取规划错误。</a:t>
-            </a:r>
-          </a:p>
-        </p:txBody>
-      </p:sp>
-      <p:sp>
-        <p:nvSpPr>
-          <p:cNvPr id="36" name="TextBox 35"/>
+              <a:t>最终要证明的不是“深度图更漂亮”，而是“机械臂少犯抓取错误”。</a:t>
+            </a:r>
+          </a:p>
+        </p:txBody>
+      </p:sp>
+      <p:sp>
+        <p:nvSpPr>
+          <p:cNvPr id="32" name="TextBox 31"/>
           <p:cNvSpPr txBox="1"/>
           <p:nvPr/>
         </p:nvSpPr>
@@ -10995,7 +11216,7 @@
                 </a:solidFill>
                 <a:latin typeface="Microsoft YaHei"/>
               </a:rPr>
-              <a:t>TransCG 下载仍以断点续传方式轮询 Google Drive 配额。</a:t>
+              <a:t>先用真实几何验证价值，再投入训练 DepthHypothesisPack。</a:t>
             </a:r>
           </a:p>
         </p:txBody>

</xml_diff>